<commit_message>
refactor(presentation): update mid-defense deck with progress breakdown slide, exact thesis title, and evaluation plan
</commit_message>
<xml_diff>
--- a/docs/scripts/Md_Riaz_Mid_Defense_Final_0322310105101024.pptx
+++ b/docs/scripts/Md_Riaz_Mid_Defense_Final_0322310105101024.pptx
@@ -736,7 +736,7 @@
           <a:lstStyle/>
           <a:p>
             <a:r>
-              <a:t>In our current prototype progress, intent extraction successfully maps user queries into bounded JSON structures. Notice that raw SQL keywords like SELECT, FROM, or WHERE are completely absent from the AI's output.</a:t>
+              <a:t>Here is our current research progress. Literature review, problem definition, and conceptual architecture design are complete. Prototype implementation is at 70%, and evaluation benchmarking is currently underway.</a:t>
             </a:r>
           </a:p>
         </p:txBody>
@@ -806,7 +806,7 @@
           <a:lstStyle/>
           <a:p>
             <a:r>
-              <a:t>For empirical evaluation, we designed a test environment using a multi-table e-commerce database. Our benchmark plan includes 100 analytical queries and 20 adversarial prompt injection attacks to rigorously evaluate security and correctness.</a:t>
+              <a:t>In our current prototype progress, intent extraction successfully maps user queries into bounded JSON structures. Notice that raw SQL keywords like SELECT, FROM, or WHERE are completely absent from the AI's output.</a:t>
             </a:r>
           </a:p>
         </p:txBody>
@@ -876,7 +876,7 @@
           <a:lstStyle/>
           <a:p>
             <a:r>
-              <a:t>We establish three quantitative metrics to evaluate AEGIS: Unsafe Query Execution Rate for security, Query Execution Validity for compilation accuracy, and Semantic Term Coverage for intent disambiguation performance.</a:t>
+              <a:t>For empirical evaluation, we designed a test environment using a multi-table e-commerce database. Our benchmark plan includes 100 analytical queries and 20 adversarial prompt injection attacks to rigorously evaluate security and correctness.</a:t>
             </a:r>
           </a:p>
         </p:txBody>
@@ -946,7 +946,7 @@
           <a:lstStyle/>
           <a:p>
             <a:r>
-              <a:t>In our preliminary testing, AEGIS achieved a 0.0% Unsafe Query Rate and 100% Execution Validity. In comparison, direct generative baselines suffered from syntax errors, invalid joins, and vulnerable query generation under injection attacks.</a:t>
+              <a:t>We establish four quantitative metrics to evaluate AEGIS: Unsafe Query Execution Rate, Query Execution Validity, Semantic Term Coverage, and Latency. Final empirical benchmark comparisons will be presented in the final defense.</a:t>
             </a:r>
           </a:p>
         </p:txBody>
@@ -1086,7 +1086,7 @@
           <a:lstStyle/>
           <a:p>
             <a:r>
-              <a:t>Moving toward our final defense, our research roadmap includes expanding benchmark testing across additional schemas, extending AST compilation to complex window functions, and completing the thesis dissertation.</a:t>
+              <a:t>Moving toward our final defense, our research roadmap includes completing benchmark testing across all 100 test queries, extending AST compilation to complex window functions, and completing the thesis dissertation.</a:t>
             </a:r>
           </a:p>
         </p:txBody>
@@ -1226,7 +1226,7 @@
           <a:lstStyle/>
           <a:p>
             <a:r>
-              <a:t>While natural language analytics is highly desirable for decision-makers, allowing Large Language Models to generate free-form SQL creates an inherent security paradox. Entrusting a stochastic neural model with direct query generation compromises database governance and execution safety.</a:t>
+              <a:t>While natural language database querying expands data access, existing systems rely on generative LLMs writing raw SQL strings directly. Entrusting a neural model with direct query generation compromises database governance and execution safety.</a:t>
             </a:r>
           </a:p>
         </p:txBody>
@@ -1506,7 +1506,7 @@
           <a:lstStyle/>
           <a:p>
             <a:r>
-              <a:t>Our research is guided by three formal research questions: First, can we perform natural language analytics without LLM-generated SQL? Second, does deterministic compilation improve database security? And third, can semantic constraints maintain analytical utility while eliminating risks?</a:t>
+              <a:t>Our research is guided by three formal research questions: First, can LLMs support natural language analytics without generating executable SQL? Second, can deterministic compilation improve safety and governance? And third, can semantic constraints maintain analytical usefulness?</a:t>
             </a:r>
           </a:p>
         </p:txBody>
@@ -6478,7 +6478,7 @@
               </a:defRPr>
             </a:pPr>
             <a:r>
-              <a:t>Implementation Progress: Intent Extraction</a:t>
+              <a:t>Current Research Progress</a:t>
             </a:r>
           </a:p>
         </p:txBody>
@@ -6507,167 +6507,433 @@
           </a:prstGeom>
         </p:spPr>
       </p:pic>
-      <p:sp>
-        <p:nvSpPr>
-          <p:cNvPr id="13" name="TextBox 12"/>
-          <p:cNvSpPr txBox="1"/>
+      <p:graphicFrame>
+        <p:nvGraphicFramePr>
+          <p:cNvPr id="13" name="Table 12"/>
+          <p:cNvGraphicFramePr>
+            <a:graphicFrameLocks noGrp="1"/>
+          </p:cNvGraphicFramePr>
           <p:nvPr/>
-        </p:nvSpPr>
-        <p:spPr>
-          <a:xfrm>
-            <a:off x="1097280" y="1645920"/>
-            <a:ext cx="10058400" cy="4114800"/>
-          </a:xfrm>
-          <a:prstGeom prst="rect">
-            <a:avLst/>
-          </a:prstGeom>
-          <a:noFill/>
-        </p:spPr>
-        <p:txBody>
-          <a:bodyPr wrap="square">
-            <a:spAutoFit/>
-          </a:bodyPr>
-          <a:lstStyle/>
-          <a:p>
-            <a:pPr>
-              <a:defRPr sz="1700">
-                <a:solidFill>
-                  <a:srgbClr val="333333"/>
-                </a:solidFill>
-              </a:defRPr>
-            </a:pPr>
-            <a:r>
-              <a:t>Natural Language Input Query: "Show me the top 5 products by total sales revenue"</a:t>
-            </a:r>
-          </a:p>
-          <a:p>
-            <a:pPr>
-              <a:defRPr sz="1700">
-                <a:solidFill>
-                  <a:srgbClr val="333333"/>
-                </a:solidFill>
-              </a:defRPr>
-            </a:pPr>
-          </a:p>
-          <a:p>
-            <a:pPr>
-              <a:defRPr sz="1700">
-                <a:solidFill>
-                  <a:srgbClr val="333333"/>
-                </a:solidFill>
-              </a:defRPr>
-            </a:pPr>
-            <a:r>
-              <a:t>Extracted Bounded Intent Payload:</a:t>
-            </a:r>
-          </a:p>
-          <a:p>
-            <a:pPr>
-              <a:defRPr sz="1700">
-                <a:solidFill>
-                  <a:srgbClr val="333333"/>
-                </a:solidFill>
-              </a:defRPr>
-            </a:pPr>
-            <a:r>
-              <a:t>{</a:t>
-            </a:r>
-          </a:p>
-          <a:p>
-            <a:pPr>
-              <a:defRPr sz="1700">
-                <a:solidFill>
-                  <a:srgbClr val="333333"/>
-                </a:solidFill>
-              </a:defRPr>
-            </a:pPr>
-            <a:r>
-              <a:t>   "intent_class": "ranking",</a:t>
-            </a:r>
-          </a:p>
-          <a:p>
-            <a:pPr>
-              <a:defRPr sz="1700">
-                <a:solidFill>
-                  <a:srgbClr val="333333"/>
-                </a:solidFill>
-              </a:defRPr>
-            </a:pPr>
-            <a:r>
-              <a:t>   "metric_term": "revenue",</a:t>
-            </a:r>
-          </a:p>
-          <a:p>
-            <a:pPr>
-              <a:defRPr sz="1700">
-                <a:solidFill>
-                  <a:srgbClr val="333333"/>
-                </a:solidFill>
-              </a:defRPr>
-            </a:pPr>
-            <a:r>
-              <a:t>   "dimension_term": "product_name",</a:t>
-            </a:r>
-          </a:p>
-          <a:p>
-            <a:pPr>
-              <a:defRPr sz="1700">
-                <a:solidFill>
-                  <a:srgbClr val="333333"/>
-                </a:solidFill>
-              </a:defRPr>
-            </a:pPr>
-            <a:r>
-              <a:t>   "sort_order": "descending",</a:t>
-            </a:r>
-          </a:p>
-          <a:p>
-            <a:pPr>
-              <a:defRPr sz="1700">
-                <a:solidFill>
-                  <a:srgbClr val="333333"/>
-                </a:solidFill>
-              </a:defRPr>
-            </a:pPr>
-            <a:r>
-              <a:t>   "limit_bounds": 5</a:t>
-            </a:r>
-          </a:p>
-          <a:p>
-            <a:pPr>
-              <a:defRPr sz="1700">
-                <a:solidFill>
-                  <a:srgbClr val="333333"/>
-                </a:solidFill>
-              </a:defRPr>
-            </a:pPr>
-            <a:r>
-              <a:t>}</a:t>
-            </a:r>
-          </a:p>
-          <a:p>
-            <a:pPr>
-              <a:defRPr sz="1700">
-                <a:solidFill>
-                  <a:srgbClr val="333333"/>
-                </a:solidFill>
-              </a:defRPr>
-            </a:pPr>
-          </a:p>
-          <a:p>
-            <a:pPr>
-              <a:defRPr sz="1700">
-                <a:solidFill>
-                  <a:srgbClr val="333333"/>
-                </a:solidFill>
-              </a:defRPr>
-            </a:pPr>
-            <a:r>
-              <a:t>Validation Gate: "revenue" is validated against Metric Registry M, and "product_name" against Dimension Taxonomy D. Malicious keywords like "DROP TABLE" fail JSON schema parsing.</a:t>
-            </a:r>
-          </a:p>
-        </p:txBody>
-      </p:sp>
+        </p:nvGraphicFramePr>
+        <p:xfrm>
+          <a:off x="731520" y="1463040"/>
+          <a:ext cx="10725912" cy="4389120"/>
+        </p:xfrm>
+        <a:graphic>
+          <a:graphicData uri="http://schemas.openxmlformats.org/drawingml/2006/table">
+            <a:tbl>
+              <a:tblPr firstRow="1" bandRow="1">
+                <a:tableStyleId>{5C22544A-7EE6-4342-B048-85BDC9FD1C3A}</a:tableStyleId>
+              </a:tblPr>
+              <a:tblGrid>
+                <a:gridCol w="3840480"/>
+                <a:gridCol w="2011680"/>
+                <a:gridCol w="4873752"/>
+              </a:tblGrid>
+              <a:tr h="548640">
+                <a:tc>
+                  <a:txBody>
+                    <a:bodyPr/>
+                    <a:lstStyle/>
+                    <a:p>
+                      <a:pPr>
+                        <a:defRPr b="1" sz="1400">
+                          <a:solidFill>
+                            <a:srgbClr val="FFFFFF"/>
+                          </a:solidFill>
+                        </a:defRPr>
+                      </a:pPr>
+                      <a:r>
+                        <a:t>Research Phase</a:t>
+                      </a:r>
+                    </a:p>
+                  </a:txBody>
+                  <a:tcPr>
+                    <a:solidFill>
+                      <a:srgbClr val="003366"/>
+                    </a:solidFill>
+                  </a:tcPr>
+                </a:tc>
+                <a:tc>
+                  <a:txBody>
+                    <a:bodyPr/>
+                    <a:lstStyle/>
+                    <a:p>
+                      <a:pPr>
+                        <a:defRPr b="1" sz="1400">
+                          <a:solidFill>
+                            <a:srgbClr val="FFFFFF"/>
+                          </a:solidFill>
+                        </a:defRPr>
+                      </a:pPr>
+                      <a:r>
+                        <a:t>Completion Status (%)</a:t>
+                      </a:r>
+                    </a:p>
+                  </a:txBody>
+                  <a:tcPr>
+                    <a:solidFill>
+                      <a:srgbClr val="003366"/>
+                    </a:solidFill>
+                  </a:tcPr>
+                </a:tc>
+                <a:tc>
+                  <a:txBody>
+                    <a:bodyPr/>
+                    <a:lstStyle/>
+                    <a:p>
+                      <a:pPr>
+                        <a:defRPr b="1" sz="1400">
+                          <a:solidFill>
+                            <a:srgbClr val="FFFFFF"/>
+                          </a:solidFill>
+                        </a:defRPr>
+                      </a:pPr>
+                      <a:r>
+                        <a:t>Current Status &amp; Key Artifacts</a:t>
+                      </a:r>
+                    </a:p>
+                  </a:txBody>
+                  <a:tcPr>
+                    <a:solidFill>
+                      <a:srgbClr val="003366"/>
+                    </a:solidFill>
+                  </a:tcPr>
+                </a:tc>
+              </a:tr>
+              <a:tr h="548640">
+                <a:tc>
+                  <a:txBody>
+                    <a:bodyPr/>
+                    <a:lstStyle/>
+                    <a:p>
+                      <a:pPr>
+                        <a:defRPr sz="1200"/>
+                      </a:pPr>
+                      <a:r>
+                        <a:t>Literature Review &amp; Gap Analysis</a:t>
+                      </a:r>
+                    </a:p>
+                  </a:txBody>
+                  <a:tcPr/>
+                </a:tc>
+                <a:tc>
+                  <a:txBody>
+                    <a:bodyPr/>
+                    <a:lstStyle/>
+                    <a:p>
+                      <a:pPr>
+                        <a:defRPr sz="1200"/>
+                      </a:pPr>
+                      <a:r>
+                        <a:t>100%</a:t>
+                      </a:r>
+                    </a:p>
+                  </a:txBody>
+                  <a:tcPr/>
+                </a:tc>
+                <a:tc>
+                  <a:txBody>
+                    <a:bodyPr/>
+                    <a:lstStyle/>
+                    <a:p>
+                      <a:pPr>
+                        <a:defRPr sz="1200"/>
+                      </a:pPr>
+                      <a:r>
+                        <a:t>Comprehensive review of RAT-SQL, DIN-SQL, RESDSQL</a:t>
+                      </a:r>
+                    </a:p>
+                  </a:txBody>
+                  <a:tcPr/>
+                </a:tc>
+              </a:tr>
+              <a:tr h="548640">
+                <a:tc>
+                  <a:txBody>
+                    <a:bodyPr/>
+                    <a:lstStyle/>
+                    <a:p>
+                      <a:pPr>
+                        <a:defRPr sz="1200"/>
+                      </a:pPr>
+                      <a:r>
+                        <a:t>Problem Definition &amp; Vulnerability Framing</a:t>
+                      </a:r>
+                    </a:p>
+                  </a:txBody>
+                  <a:tcPr/>
+                </a:tc>
+                <a:tc>
+                  <a:txBody>
+                    <a:bodyPr/>
+                    <a:lstStyle/>
+                    <a:p>
+                      <a:pPr>
+                        <a:defRPr sz="1200"/>
+                      </a:pPr>
+                      <a:r>
+                        <a:t>100%</a:t>
+                      </a:r>
+                    </a:p>
+                  </a:txBody>
+                  <a:tcPr/>
+                </a:tc>
+                <a:tc>
+                  <a:txBody>
+                    <a:bodyPr/>
+                    <a:lstStyle/>
+                    <a:p>
+                      <a:pPr>
+                        <a:defRPr sz="1200"/>
+                      </a:pPr>
+                      <a:r>
+                        <a:t>Formalization of 3 Vulnerability Classes &amp; RQs</a:t>
+                      </a:r>
+                    </a:p>
+                  </a:txBody>
+                  <a:tcPr/>
+                </a:tc>
+              </a:tr>
+              <a:tr h="548640">
+                <a:tc>
+                  <a:txBody>
+                    <a:bodyPr/>
+                    <a:lstStyle/>
+                    <a:p>
+                      <a:pPr>
+                        <a:defRPr sz="1200"/>
+                      </a:pPr>
+                      <a:r>
+                        <a:t>Conceptual Architecture Design</a:t>
+                      </a:r>
+                    </a:p>
+                  </a:txBody>
+                  <a:tcPr/>
+                </a:tc>
+                <a:tc>
+                  <a:txBody>
+                    <a:bodyPr/>
+                    <a:lstStyle/>
+                    <a:p>
+                      <a:pPr>
+                        <a:defRPr sz="1200"/>
+                      </a:pPr>
+                      <a:r>
+                        <a:t>100%</a:t>
+                      </a:r>
+                    </a:p>
+                  </a:txBody>
+                  <a:tcPr/>
+                </a:tc>
+                <a:tc>
+                  <a:txBody>
+                    <a:bodyPr/>
+                    <a:lstStyle/>
+                    <a:p>
+                      <a:pPr>
+                        <a:defRPr sz="1200"/>
+                      </a:pPr>
+                      <a:r>
+                        <a:t>7-Stage Decoupled Pipeline &amp; Threat Model</a:t>
+                      </a:r>
+                    </a:p>
+                  </a:txBody>
+                  <a:tcPr/>
+                </a:tc>
+              </a:tr>
+              <a:tr h="548640">
+                <a:tc>
+                  <a:txBody>
+                    <a:bodyPr/>
+                    <a:lstStyle/>
+                    <a:p>
+                      <a:pPr>
+                        <a:defRPr sz="1200"/>
+                      </a:pPr>
+                      <a:r>
+                        <a:t>Closed Semantic Layer Specification</a:t>
+                      </a:r>
+                    </a:p>
+                  </a:txBody>
+                  <a:tcPr/>
+                </a:tc>
+                <a:tc>
+                  <a:txBody>
+                    <a:bodyPr/>
+                    <a:lstStyle/>
+                    <a:p>
+                      <a:pPr>
+                        <a:defRPr sz="1200"/>
+                      </a:pPr>
+                      <a:r>
+                        <a:t>80%</a:t>
+                      </a:r>
+                    </a:p>
+                  </a:txBody>
+                  <a:tcPr/>
+                </a:tc>
+                <a:tc>
+                  <a:txBody>
+                    <a:bodyPr/>
+                    <a:lstStyle/>
+                    <a:p>
+                      <a:pPr>
+                        <a:defRPr sz="1200"/>
+                      </a:pPr>
+                      <a:r>
+                        <a:t>Metric &amp; Dimension whitelist taxonomies defined</a:t>
+                      </a:r>
+                    </a:p>
+                  </a:txBody>
+                  <a:tcPr/>
+                </a:tc>
+              </a:tr>
+              <a:tr h="548640">
+                <a:tc>
+                  <a:txBody>
+                    <a:bodyPr/>
+                    <a:lstStyle/>
+                    <a:p>
+                      <a:pPr>
+                        <a:defRPr sz="1200"/>
+                      </a:pPr>
+                      <a:r>
+                        <a:t>Prototype &amp; AST Compiler Implementation</a:t>
+                      </a:r>
+                    </a:p>
+                  </a:txBody>
+                  <a:tcPr/>
+                </a:tc>
+                <a:tc>
+                  <a:txBody>
+                    <a:bodyPr/>
+                    <a:lstStyle/>
+                    <a:p>
+                      <a:pPr>
+                        <a:defRPr sz="1200"/>
+                      </a:pPr>
+                      <a:r>
+                        <a:t>70%</a:t>
+                      </a:r>
+                    </a:p>
+                  </a:txBody>
+                  <a:tcPr/>
+                </a:tc>
+                <a:tc>
+                  <a:txBody>
+                    <a:bodyPr/>
+                    <a:lstStyle/>
+                    <a:p>
+                      <a:pPr>
+                        <a:defRPr sz="1200"/>
+                      </a:pPr>
+                      <a:r>
+                        <a:t>JSON Intent Extractor &amp; BFS Join Compiler built</a:t>
+                      </a:r>
+                    </a:p>
+                  </a:txBody>
+                  <a:tcPr/>
+                </a:tc>
+              </a:tr>
+              <a:tr h="548640">
+                <a:tc>
+                  <a:txBody>
+                    <a:bodyPr/>
+                    <a:lstStyle/>
+                    <a:p>
+                      <a:pPr>
+                        <a:defRPr sz="1200"/>
+                      </a:pPr>
+                      <a:r>
+                        <a:t>Experimental Evaluation &amp; Benchmarking</a:t>
+                      </a:r>
+                    </a:p>
+                  </a:txBody>
+                  <a:tcPr/>
+                </a:tc>
+                <a:tc>
+                  <a:txBody>
+                    <a:bodyPr/>
+                    <a:lstStyle/>
+                    <a:p>
+                      <a:pPr>
+                        <a:defRPr sz="1200"/>
+                      </a:pPr>
+                      <a:r>
+                        <a:t>40%</a:t>
+                      </a:r>
+                    </a:p>
+                  </a:txBody>
+                  <a:tcPr/>
+                </a:tc>
+                <a:tc>
+                  <a:txBody>
+                    <a:bodyPr/>
+                    <a:lstStyle/>
+                    <a:p>
+                      <a:pPr>
+                        <a:defRPr sz="1200"/>
+                      </a:pPr>
+                      <a:r>
+                        <a:t>100 test query suite &amp; injection cases prepared</a:t>
+                      </a:r>
+                    </a:p>
+                  </a:txBody>
+                  <a:tcPr/>
+                </a:tc>
+              </a:tr>
+              <a:tr h="548640">
+                <a:tc>
+                  <a:txBody>
+                    <a:bodyPr/>
+                    <a:lstStyle/>
+                    <a:p>
+                      <a:pPr>
+                        <a:defRPr sz="1200"/>
+                      </a:pPr>
+                      <a:r>
+                        <a:t>Thesis Writing &amp; Dissertation Draft</a:t>
+                      </a:r>
+                    </a:p>
+                  </a:txBody>
+                  <a:tcPr/>
+                </a:tc>
+                <a:tc>
+                  <a:txBody>
+                    <a:bodyPr/>
+                    <a:lstStyle/>
+                    <a:p>
+                      <a:pPr>
+                        <a:defRPr sz="1200"/>
+                      </a:pPr>
+                      <a:r>
+                        <a:t>50%</a:t>
+                      </a:r>
+                    </a:p>
+                  </a:txBody>
+                  <a:tcPr/>
+                </a:tc>
+                <a:tc>
+                  <a:txBody>
+                    <a:bodyPr/>
+                    <a:lstStyle/>
+                    <a:p>
+                      <a:pPr>
+                        <a:defRPr sz="1200"/>
+                      </a:pPr>
+                      <a:r>
+                        <a:t>Drafted background, literature review, &amp; design chapters</a:t>
+                      </a:r>
+                    </a:p>
+                  </a:txBody>
+                  <a:tcPr/>
+                </a:tc>
+              </a:tr>
+            </a:tbl>
+          </a:graphicData>
+        </a:graphic>
+      </p:graphicFrame>
     </p:spTree>
   </p:cSld>
   <p:clrMapOvr>
@@ -6905,7 +7171,7 @@
               </a:defRPr>
             </a:pPr>
             <a:r>
-              <a:t>Experimental Setup &amp; Evaluation Plan</a:t>
+              <a:t>Implementation Progress: Intent Extraction Demo</a:t>
             </a:r>
           </a:p>
         </p:txBody>
@@ -6957,104 +7223,140 @@
           <a:lstStyle/>
           <a:p>
             <a:pPr>
-              <a:defRPr sz="1800">
+              <a:defRPr sz="1700">
                 <a:solidFill>
                   <a:srgbClr val="333333"/>
                 </a:solidFill>
               </a:defRPr>
             </a:pPr>
             <a:r>
-              <a:t>Evaluation Environment &amp; Database Schema:</a:t>
+              <a:t>Natural Language Input Query: "Show me the top 5 products by total sales revenue"</a:t>
             </a:r>
           </a:p>
           <a:p>
             <a:pPr>
-              <a:defRPr sz="1800">
+              <a:defRPr sz="1700">
                 <a:solidFill>
                   <a:srgbClr val="333333"/>
                 </a:solidFill>
               </a:defRPr>
             </a:pPr>
-            <a:r>
-              <a:t>• Evaluated over a multi-table e-commerce relational database schema (nopCommerce).</a:t>
-            </a:r>
           </a:p>
           <a:p>
             <a:pPr>
-              <a:defRPr sz="1800">
+              <a:defRPr sz="1700">
                 <a:solidFill>
                   <a:srgbClr val="333333"/>
                 </a:solidFill>
               </a:defRPr>
             </a:pPr>
             <a:r>
-              <a:t>• Benchmark dataset comprising 100 multi-level analytical queries across 11 core primitives.</a:t>
+              <a:t>Extracted Bounded Intent Payload:</a:t>
             </a:r>
           </a:p>
           <a:p>
             <a:pPr>
-              <a:defRPr sz="1800">
+              <a:defRPr sz="1700">
                 <a:solidFill>
                   <a:srgbClr val="333333"/>
                 </a:solidFill>
               </a:defRPr>
             </a:pPr>
+            <a:r>
+              <a:t>{</a:t>
+            </a:r>
           </a:p>
           <a:p>
             <a:pPr>
-              <a:defRPr sz="1800">
+              <a:defRPr sz="1700">
                 <a:solidFill>
                   <a:srgbClr val="333333"/>
                 </a:solidFill>
               </a:defRPr>
             </a:pPr>
             <a:r>
-              <a:t>Adversarial Security Test Set:</a:t>
+              <a:t>   "intent_class": "ranking",</a:t>
             </a:r>
           </a:p>
           <a:p>
             <a:pPr>
-              <a:defRPr sz="1800">
+              <a:defRPr sz="1700">
                 <a:solidFill>
                   <a:srgbClr val="333333"/>
                 </a:solidFill>
               </a:defRPr>
             </a:pPr>
             <a:r>
-              <a:t>• Includes 20 adversarial prompt injection queries designed to attempt unauthorized DML/DDL execution and system instruction overrides.</a:t>
+              <a:t>   "metric_term": "revenue",</a:t>
             </a:r>
           </a:p>
           <a:p>
             <a:pPr>
-              <a:defRPr sz="1800">
+              <a:defRPr sz="1700">
                 <a:solidFill>
                   <a:srgbClr val="333333"/>
                 </a:solidFill>
               </a:defRPr>
             </a:pPr>
+            <a:r>
+              <a:t>   "dimension_term": "product_name",</a:t>
+            </a:r>
           </a:p>
           <a:p>
             <a:pPr>
-              <a:defRPr sz="1800">
+              <a:defRPr sz="1700">
                 <a:solidFill>
                   <a:srgbClr val="333333"/>
                 </a:solidFill>
               </a:defRPr>
             </a:pPr>
             <a:r>
-              <a:t>Baseline Benchmark Model:</a:t>
+              <a:t>   "sort_order": "descending",</a:t>
             </a:r>
           </a:p>
           <a:p>
             <a:pPr>
-              <a:defRPr sz="1800">
+              <a:defRPr sz="1700">
                 <a:solidFill>
                   <a:srgbClr val="333333"/>
                 </a:solidFill>
               </a:defRPr>
             </a:pPr>
             <a:r>
-              <a:t>• Direct zero-shot LLM SQL generation (Direct Generative Baseline).</a:t>
+              <a:t>   "limit_bounds": 5</a:t>
+            </a:r>
+          </a:p>
+          <a:p>
+            <a:pPr>
+              <a:defRPr sz="1700">
+                <a:solidFill>
+                  <a:srgbClr val="333333"/>
+                </a:solidFill>
+              </a:defRPr>
+            </a:pPr>
+            <a:r>
+              <a:t>}</a:t>
+            </a:r>
+          </a:p>
+          <a:p>
+            <a:pPr>
+              <a:defRPr sz="1700">
+                <a:solidFill>
+                  <a:srgbClr val="333333"/>
+                </a:solidFill>
+              </a:defRPr>
+            </a:pPr>
+          </a:p>
+          <a:p>
+            <a:pPr>
+              <a:defRPr sz="1700">
+                <a:solidFill>
+                  <a:srgbClr val="333333"/>
+                </a:solidFill>
+              </a:defRPr>
+            </a:pPr>
+            <a:r>
+              <a:t>Validation Gate: "revenue" is validated against Metric Registry M, and "product_name" against Dimension Taxonomy D. Malicious keywords like "DROP TABLE" fail JSON schema parsing.</a:t>
             </a:r>
           </a:p>
         </p:txBody>
@@ -7296,7 +7598,7 @@
               </a:defRPr>
             </a:pPr>
             <a:r>
-              <a:t>Quantitative Evaluation Metrics</a:t>
+              <a:t>Experimental Setup &amp; Benchmark Plan</a:t>
             </a:r>
           </a:p>
         </p:txBody>
@@ -7325,6 +7627,397 @@
           </a:prstGeom>
         </p:spPr>
       </p:pic>
+      <p:sp>
+        <p:nvSpPr>
+          <p:cNvPr id="13" name="TextBox 12"/>
+          <p:cNvSpPr txBox="1"/>
+          <p:nvPr/>
+        </p:nvSpPr>
+        <p:spPr>
+          <a:xfrm>
+            <a:off x="1097280" y="1645920"/>
+            <a:ext cx="10058400" cy="4114800"/>
+          </a:xfrm>
+          <a:prstGeom prst="rect">
+            <a:avLst/>
+          </a:prstGeom>
+          <a:noFill/>
+        </p:spPr>
+        <p:txBody>
+          <a:bodyPr wrap="square">
+            <a:spAutoFit/>
+          </a:bodyPr>
+          <a:lstStyle/>
+          <a:p>
+            <a:pPr>
+              <a:defRPr sz="1800">
+                <a:solidFill>
+                  <a:srgbClr val="333333"/>
+                </a:solidFill>
+              </a:defRPr>
+            </a:pPr>
+            <a:r>
+              <a:t>Evaluation Environment &amp; Database Schema:</a:t>
+            </a:r>
+          </a:p>
+          <a:p>
+            <a:pPr>
+              <a:defRPr sz="1800">
+                <a:solidFill>
+                  <a:srgbClr val="333333"/>
+                </a:solidFill>
+              </a:defRPr>
+            </a:pPr>
+            <a:r>
+              <a:t>• Evaluated over a multi-table e-commerce relational database schema (nopCommerce).</a:t>
+            </a:r>
+          </a:p>
+          <a:p>
+            <a:pPr>
+              <a:defRPr sz="1800">
+                <a:solidFill>
+                  <a:srgbClr val="333333"/>
+                </a:solidFill>
+              </a:defRPr>
+            </a:pPr>
+            <a:r>
+              <a:t>• Benchmark dataset comprising 100 multi-level analytical queries across 11 core primitives.</a:t>
+            </a:r>
+          </a:p>
+          <a:p>
+            <a:pPr>
+              <a:defRPr sz="1800">
+                <a:solidFill>
+                  <a:srgbClr val="333333"/>
+                </a:solidFill>
+              </a:defRPr>
+            </a:pPr>
+          </a:p>
+          <a:p>
+            <a:pPr>
+              <a:defRPr sz="1800">
+                <a:solidFill>
+                  <a:srgbClr val="333333"/>
+                </a:solidFill>
+              </a:defRPr>
+            </a:pPr>
+            <a:r>
+              <a:t>Adversarial Security Test Set:</a:t>
+            </a:r>
+          </a:p>
+          <a:p>
+            <a:pPr>
+              <a:defRPr sz="1800">
+                <a:solidFill>
+                  <a:srgbClr val="333333"/>
+                </a:solidFill>
+              </a:defRPr>
+            </a:pPr>
+            <a:r>
+              <a:t>• Includes 20 adversarial prompt injection queries designed to attempt unauthorized DML/DDL execution and system instruction overrides.</a:t>
+            </a:r>
+          </a:p>
+          <a:p>
+            <a:pPr>
+              <a:defRPr sz="1800">
+                <a:solidFill>
+                  <a:srgbClr val="333333"/>
+                </a:solidFill>
+              </a:defRPr>
+            </a:pPr>
+          </a:p>
+          <a:p>
+            <a:pPr>
+              <a:defRPr sz="1800">
+                <a:solidFill>
+                  <a:srgbClr val="333333"/>
+                </a:solidFill>
+              </a:defRPr>
+            </a:pPr>
+            <a:r>
+              <a:t>Baseline Benchmark Model:</a:t>
+            </a:r>
+          </a:p>
+          <a:p>
+            <a:pPr>
+              <a:defRPr sz="1800">
+                <a:solidFill>
+                  <a:srgbClr val="333333"/>
+                </a:solidFill>
+              </a:defRPr>
+            </a:pPr>
+            <a:r>
+              <a:t>• Direct zero-shot LLM SQL generation (Direct Generative Baseline).</a:t>
+            </a:r>
+          </a:p>
+        </p:txBody>
+      </p:sp>
+    </p:spTree>
+  </p:cSld>
+  <p:clrMapOvr>
+    <a:masterClrMapping/>
+  </p:clrMapOvr>
+</p:sld>
+</file>
+
+<file path=ppt/slides/slide15.xml><?xml version="1.0" encoding="utf-8"?>
+<p:sld xmlns:a="http://schemas.openxmlformats.org/drawingml/2006/main" xmlns:p="http://schemas.openxmlformats.org/presentationml/2006/main" xmlns:r="http://schemas.openxmlformats.org/officeDocument/2006/relationships">
+  <p:cSld>
+    <p:spTree>
+      <p:nvGrpSpPr>
+        <p:cNvPr id="1" name=""/>
+        <p:cNvGrpSpPr/>
+        <p:nvPr/>
+      </p:nvGrpSpPr>
+      <p:grpSpPr/>
+      <p:sp>
+        <p:nvSpPr>
+          <p:cNvPr id="11" name="Rectangle 10">
+            <a:extLst>
+              <a:ext uri="{FF2B5EF4-FFF2-40B4-BE49-F238E27FC236}">
+                <a16:creationId xmlns:a16="http://schemas.microsoft.com/office/drawing/2014/main" id="{D059D760-A365-91EB-B942-587B657A477E}"/>
+              </a:ext>
+            </a:extLst>
+          </p:cNvPr>
+          <p:cNvSpPr/>
+          <p:nvPr/>
+        </p:nvSpPr>
+        <p:spPr>
+          <a:xfrm>
+            <a:off x="-1" y="1500807"/>
+            <a:ext cx="12191999" cy="18288"/>
+          </a:xfrm>
+          <a:prstGeom prst="rect">
+            <a:avLst/>
+          </a:prstGeom>
+          <a:gradFill flip="none" rotWithShape="1">
+            <a:gsLst>
+              <a:gs pos="0">
+                <a:schemeClr val="accent1">
+                  <a:lumMod val="40000"/>
+                  <a:lumOff val="60000"/>
+                </a:schemeClr>
+              </a:gs>
+              <a:gs pos="36000">
+                <a:schemeClr val="accent1">
+                  <a:lumMod val="95000"/>
+                  <a:lumOff val="5000"/>
+                </a:schemeClr>
+              </a:gs>
+              <a:gs pos="100000">
+                <a:schemeClr val="tx2">
+                  <a:lumMod val="50000"/>
+                </a:schemeClr>
+              </a:gs>
+            </a:gsLst>
+            <a:path path="circle">
+              <a:fillToRect l="50000" t="130000" r="50000" b="-30000"/>
+            </a:path>
+            <a:tileRect/>
+          </a:gradFill>
+          <a:ln>
+            <a:noFill/>
+          </a:ln>
+        </p:spPr>
+        <p:style>
+          <a:lnRef idx="2">
+            <a:schemeClr val="accent1">
+              <a:shade val="15000"/>
+            </a:schemeClr>
+          </a:lnRef>
+          <a:fillRef idx="1">
+            <a:schemeClr val="accent1"/>
+          </a:fillRef>
+          <a:effectRef idx="0">
+            <a:schemeClr val="accent1"/>
+          </a:effectRef>
+          <a:fontRef idx="minor">
+            <a:schemeClr val="lt1"/>
+          </a:fontRef>
+        </p:style>
+        <p:txBody>
+          <a:bodyPr rtlCol="0" anchor="ctr"/>
+          <a:lstStyle/>
+          <a:p>
+            <a:pPr algn="ctr"/>
+            <a:endParaRPr lang="en-US"/>
+          </a:p>
+        </p:txBody>
+      </p:sp>
+      <p:sp>
+        <p:nvSpPr>
+          <p:cNvPr id="7" name="Rectangle 6">
+            <a:extLst>
+              <a:ext uri="{FF2B5EF4-FFF2-40B4-BE49-F238E27FC236}">
+                <a16:creationId xmlns:a16="http://schemas.microsoft.com/office/drawing/2014/main" id="{37F49795-9FC6-D65C-AAE9-247F6DF3DA3F}"/>
+              </a:ext>
+            </a:extLst>
+          </p:cNvPr>
+          <p:cNvSpPr/>
+          <p:nvPr/>
+        </p:nvSpPr>
+        <p:spPr>
+          <a:xfrm>
+            <a:off x="0" y="6291468"/>
+            <a:ext cx="12192000" cy="586409"/>
+          </a:xfrm>
+          <a:prstGeom prst="rect">
+            <a:avLst/>
+          </a:prstGeom>
+          <a:solidFill>
+            <a:schemeClr val="tx2">
+              <a:lumMod val="75000"/>
+            </a:schemeClr>
+          </a:solidFill>
+          <a:ln>
+            <a:noFill/>
+          </a:ln>
+          <a:effectLst>
+            <a:outerShdw blurRad="63500" sx="102000" sy="102000" algn="ctr" rotWithShape="0">
+              <a:prstClr val="black">
+                <a:alpha val="40000"/>
+              </a:prstClr>
+            </a:outerShdw>
+          </a:effectLst>
+        </p:spPr>
+        <p:style>
+          <a:lnRef idx="2">
+            <a:schemeClr val="accent1">
+              <a:shade val="15000"/>
+            </a:schemeClr>
+          </a:lnRef>
+          <a:fillRef idx="1">
+            <a:schemeClr val="accent1"/>
+          </a:fillRef>
+          <a:effectRef idx="0">
+            <a:schemeClr val="accent1"/>
+          </a:effectRef>
+          <a:fontRef idx="minor">
+            <a:schemeClr val="lt1"/>
+          </a:fontRef>
+        </p:style>
+        <p:txBody>
+          <a:bodyPr rtlCol="0" anchor="ctr"/>
+          <a:lstStyle/>
+          <a:p>
+            <a:pPr algn="ctr"/>
+            <a:endParaRPr lang="en-US" dirty="0"/>
+          </a:p>
+        </p:txBody>
+      </p:sp>
+      <p:sp>
+        <p:nvSpPr>
+          <p:cNvPr id="3" name="Rectangle 2">
+            <a:extLst>
+              <a:ext uri="{FF2B5EF4-FFF2-40B4-BE49-F238E27FC236}">
+                <a16:creationId xmlns:a16="http://schemas.microsoft.com/office/drawing/2014/main" id="{6027AE48-C47C-33FE-8F56-0AA4260C9B62}"/>
+              </a:ext>
+            </a:extLst>
+          </p:cNvPr>
+          <p:cNvSpPr/>
+          <p:nvPr/>
+        </p:nvSpPr>
+        <p:spPr>
+          <a:xfrm>
+            <a:off x="0" y="0"/>
+            <a:ext cx="12192000" cy="1500809"/>
+          </a:xfrm>
+          <a:prstGeom prst="rect">
+            <a:avLst/>
+          </a:prstGeom>
+          <a:solidFill>
+            <a:schemeClr val="accent1">
+              <a:lumMod val="20000"/>
+              <a:lumOff val="80000"/>
+            </a:schemeClr>
+          </a:solidFill>
+          <a:ln>
+            <a:noFill/>
+          </a:ln>
+          <a:effectLst/>
+        </p:spPr>
+        <p:style>
+          <a:lnRef idx="2">
+            <a:schemeClr val="accent1">
+              <a:shade val="15000"/>
+            </a:schemeClr>
+          </a:lnRef>
+          <a:fillRef idx="1">
+            <a:schemeClr val="accent1"/>
+          </a:fillRef>
+          <a:effectRef idx="0">
+            <a:schemeClr val="accent1"/>
+          </a:effectRef>
+          <a:fontRef idx="minor">
+            <a:schemeClr val="lt1"/>
+          </a:fontRef>
+        </p:style>
+        <p:txBody>
+          <a:bodyPr rtlCol="0" anchor="ctr"/>
+          <a:lstStyle/>
+          <a:p>
+            <a:pPr algn="ctr"/>
+            <a:endParaRPr lang="en-US" dirty="0"/>
+          </a:p>
+        </p:txBody>
+      </p:sp>
+      <p:sp>
+        <p:nvSpPr>
+          <p:cNvPr id="2" name="Title 1"/>
+          <p:cNvSpPr>
+            <a:spLocks noGrp="1"/>
+          </p:cNvSpPr>
+          <p:nvPr>
+            <p:ph type="title"/>
+          </p:nvPr>
+        </p:nvSpPr>
+        <p:spPr>
+          <a:xfrm>
+            <a:off x="1188720" y="365760"/>
+            <a:ext cx="9601200" cy="731520"/>
+          </a:xfrm>
+        </p:spPr>
+        <p:txBody>
+          <a:bodyPr/>
+          <a:lstStyle/>
+          <a:p>
+            <a:pPr>
+              <a:defRPr b="1" sz="2400">
+                <a:solidFill>
+                  <a:srgbClr val="003366"/>
+                </a:solidFill>
+              </a:defRPr>
+            </a:pPr>
+            <a:r>
+              <a:t>Quantitative Evaluation Metrics &amp; Expected Results</a:t>
+            </a:r>
+          </a:p>
+        </p:txBody>
+      </p:sp>
+      <p:pic>
+        <p:nvPicPr>
+          <p:cNvPr id="12" name="Picture 11" descr="image.png"/>
+          <p:cNvPicPr>
+            <a:picLocks noChangeAspect="1"/>
+          </p:cNvPicPr>
+          <p:nvPr/>
+        </p:nvPicPr>
+        <p:blipFill>
+          <a:blip r:embed="rId2"/>
+          <a:stretch>
+            <a:fillRect/>
+          </a:stretch>
+        </p:blipFill>
+        <p:spPr>
+          <a:xfrm>
+            <a:off x="512874" y="457199"/>
+            <a:ext cx="592309" cy="586409"/>
+          </a:xfrm>
+          <a:prstGeom prst="rect">
+            <a:avLst/>
+          </a:prstGeom>
+        </p:spPr>
+      </p:pic>
       <p:graphicFrame>
         <p:nvGraphicFramePr>
           <p:cNvPr id="13" name="Table 12"/>
@@ -7335,7 +8028,7 @@
         </p:nvGraphicFramePr>
         <p:xfrm>
           <a:off x="914400" y="1645920"/>
-          <a:ext cx="10332720" cy="3657600"/>
+          <a:ext cx="10332720" cy="3840480"/>
         </p:xfrm>
         <a:graphic>
           <a:graphicData uri="http://schemas.openxmlformats.org/drawingml/2006/table">
@@ -7348,7 +8041,7 @@
                 <a:gridCol w="2560320"/>
                 <a:gridCol w="4297680"/>
               </a:tblGrid>
-              <a:tr h="914400">
+              <a:tr h="768096">
                 <a:tc>
                   <a:txBody>
                     <a:bodyPr/>
@@ -7385,7 +8078,7 @@
                         </a:defRPr>
                       </a:pPr>
                       <a:r>
-                        <a:t>Scientific Focus</a:t>
+                        <a:t>Purpose &amp; Focus</a:t>
                       </a:r>
                     </a:p>
                   </a:txBody>
@@ -7408,7 +8101,7 @@
                         </a:defRPr>
                       </a:pPr>
                       <a:r>
-                        <a:t>Evaluation Methodology</a:t>
+                        <a:t>Expected Outcome / Observation</a:t>
                       </a:r>
                     </a:p>
                   </a:txBody>
@@ -7419,14 +8112,14 @@
                   </a:tcPr>
                 </a:tc>
               </a:tr>
-              <a:tr h="914400">
+              <a:tr h="768096">
                 <a:tc>
                   <a:txBody>
                     <a:bodyPr/>
                     <a:lstStyle/>
                     <a:p>
                       <a:pPr>
-                        <a:defRPr sz="1300"/>
+                        <a:defRPr sz="1200"/>
                       </a:pPr>
                       <a:r>
                         <a:t>Unsafe Query Execution Rate (UQER)</a:t>
@@ -7441,7 +8134,7 @@
                     <a:lstStyle/>
                     <a:p>
                       <a:pPr>
-                        <a:defRPr sz="1300"/>
+                        <a:defRPr sz="1200"/>
                       </a:pPr>
                       <a:r>
                         <a:t>Security &amp; Governance</a:t>
@@ -7456,24 +8149,24 @@
                     <a:lstStyle/>
                     <a:p>
                       <a:pPr>
-                        <a:defRPr sz="1300"/>
+                        <a:defRPr sz="1200"/>
                       </a:pPr>
                       <a:r>
-                        <a:t>Percentage of compiled queries emitting unauthorized DML/DDL code under adversarial attacks.</a:t>
+                        <a:t>Zero unauthorized DML/DDL emissions under adversarial prompt injection attacks.</a:t>
                       </a:r>
                     </a:p>
                   </a:txBody>
                   <a:tcPr/>
                 </a:tc>
               </a:tr>
-              <a:tr h="914400">
+              <a:tr h="768096">
                 <a:tc>
                   <a:txBody>
                     <a:bodyPr/>
                     <a:lstStyle/>
                     <a:p>
                       <a:pPr>
-                        <a:defRPr sz="1300"/>
+                        <a:defRPr sz="1200"/>
                       </a:pPr>
                       <a:r>
                         <a:t>Query Execution Validity (QEV)</a:t>
@@ -7488,7 +8181,7 @@
                     <a:lstStyle/>
                     <a:p>
                       <a:pPr>
-                        <a:defRPr sz="1300"/>
+                        <a:defRPr sz="1200"/>
                       </a:pPr>
                       <a:r>
                         <a:t>Execution Accuracy</a:t>
@@ -7503,24 +8196,24 @@
                     <a:lstStyle/>
                     <a:p>
                       <a:pPr>
-                        <a:defRPr sz="1300"/>
+                        <a:defRPr sz="1200"/>
                       </a:pPr>
                       <a:r>
-                        <a:t>Ratio of compiled SQL queries executing successfully without syntax errors or invalid join paths.</a:t>
+                        <a:t>High compilation validity by eliminating syntax errors and hallucinated join paths.</a:t>
                       </a:r>
                     </a:p>
                   </a:txBody>
                   <a:tcPr/>
                 </a:tc>
               </a:tr>
-              <a:tr h="914400">
+              <a:tr h="768096">
                 <a:tc>
                   <a:txBody>
                     <a:bodyPr/>
                     <a:lstStyle/>
                     <a:p>
                       <a:pPr>
-                        <a:defRPr sz="1300"/>
+                        <a:defRPr sz="1200"/>
                       </a:pPr>
                       <a:r>
                         <a:t>Semantic Term Coverage (STC)</a:t>
@@ -7535,7 +8228,7 @@
                     <a:lstStyle/>
                     <a:p>
                       <a:pPr>
-                        <a:defRPr sz="1300"/>
+                        <a:defRPr sz="1200"/>
                       </a:pPr>
                       <a:r>
                         <a:t>Intent Disambiguation</a:t>
@@ -7550,10 +8243,57 @@
                     <a:lstStyle/>
                     <a:p>
                       <a:pPr>
-                        <a:defRPr sz="1300"/>
+                        <a:defRPr sz="1200"/>
                       </a:pPr>
                       <a:r>
-                        <a:t>Accuracy of the LLM in mapping natural language phrases to valid closed-vocabulary terms.</a:t>
+                        <a:t>Accurate mapping of natural language phrases to whitelisted semantic tokens.</a:t>
+                      </a:r>
+                    </a:p>
+                  </a:txBody>
+                  <a:tcPr/>
+                </a:tc>
+              </a:tr>
+              <a:tr h="768096">
+                <a:tc>
+                  <a:txBody>
+                    <a:bodyPr/>
+                    <a:lstStyle/>
+                    <a:p>
+                      <a:pPr>
+                        <a:defRPr sz="1200"/>
+                      </a:pPr>
+                      <a:r>
+                        <a:t>Inference &amp; Compilation Latency</a:t>
+                      </a:r>
+                    </a:p>
+                  </a:txBody>
+                  <a:tcPr/>
+                </a:tc>
+                <a:tc>
+                  <a:txBody>
+                    <a:bodyPr/>
+                    <a:lstStyle/>
+                    <a:p>
+                      <a:pPr>
+                        <a:defRPr sz="1200"/>
+                      </a:pPr>
+                      <a:r>
+                        <a:t>Execution Efficiency</a:t>
+                      </a:r>
+                    </a:p>
+                  </a:txBody>
+                  <a:tcPr/>
+                </a:tc>
+                <a:tc>
+                  <a:txBody>
+                    <a:bodyPr/>
+                    <a:lstStyle/>
+                    <a:p>
+                      <a:pPr>
+                        <a:defRPr sz="1200"/>
+                      </a:pPr>
+                      <a:r>
+                        <a:t>Acceptable response latency suitable for interactive analytical environments.</a:t>
                       </a:r>
                     </a:p>
                   </a:txBody>
@@ -7572,7 +8312,7 @@
 </p:sld>
 </file>
 
-<file path=ppt/slides/slide15.xml><?xml version="1.0" encoding="utf-8"?>
+<file path=ppt/slides/slide16.xml><?xml version="1.0" encoding="utf-8"?>
 <p:sld xmlns:a="http://schemas.openxmlformats.org/drawingml/2006/main" xmlns:p="http://schemas.openxmlformats.org/presentationml/2006/main" xmlns:r="http://schemas.openxmlformats.org/officeDocument/2006/relationships">
   <p:cSld>
     <p:spTree>
@@ -7801,7 +8541,7 @@
               </a:defRPr>
             </a:pPr>
             <a:r>
-              <a:t>Preliminary Evaluation Results</a:t>
+              <a:t>System Scope &amp; Limitations</a:t>
             </a:r>
           </a:p>
         </p:txBody>
@@ -7830,255 +8570,16 @@
           </a:prstGeom>
         </p:spPr>
       </p:pic>
-      <p:graphicFrame>
-        <p:nvGraphicFramePr>
-          <p:cNvPr id="13" name="Table 12"/>
-          <p:cNvGraphicFramePr>
-            <a:graphicFrameLocks noGrp="1"/>
-          </p:cNvGraphicFramePr>
-          <p:nvPr/>
-        </p:nvGraphicFramePr>
-        <p:xfrm>
-          <a:off x="1965960" y="1828800"/>
-          <a:ext cx="8229600" cy="2560320"/>
-        </p:xfrm>
-        <a:graphic>
-          <a:graphicData uri="http://schemas.openxmlformats.org/drawingml/2006/table">
-            <a:tbl>
-              <a:tblPr firstRow="1" bandRow="1">
-                <a:tableStyleId>{5C22544A-7EE6-4342-B048-85BDC9FD1C3A}</a:tableStyleId>
-              </a:tblPr>
-              <a:tblGrid>
-                <a:gridCol w="2743200"/>
-                <a:gridCol w="2743200"/>
-                <a:gridCol w="2743200"/>
-              </a:tblGrid>
-              <a:tr h="640080">
-                <a:tc>
-                  <a:txBody>
-                    <a:bodyPr/>
-                    <a:lstStyle/>
-                    <a:p>
-                      <a:pPr>
-                        <a:defRPr b="1" sz="1500">
-                          <a:solidFill>
-                            <a:srgbClr val="FFFFFF"/>
-                          </a:solidFill>
-                        </a:defRPr>
-                      </a:pPr>
-                      <a:r>
-                        <a:t>Performance Metric</a:t>
-                      </a:r>
-                    </a:p>
-                  </a:txBody>
-                  <a:tcPr>
-                    <a:solidFill>
-                      <a:srgbClr val="003366"/>
-                    </a:solidFill>
-                  </a:tcPr>
-                </a:tc>
-                <a:tc>
-                  <a:txBody>
-                    <a:bodyPr/>
-                    <a:lstStyle/>
-                    <a:p>
-                      <a:pPr>
-                        <a:defRPr b="1" sz="1500">
-                          <a:solidFill>
-                            <a:srgbClr val="FFFFFF"/>
-                          </a:solidFill>
-                        </a:defRPr>
-                      </a:pPr>
-                      <a:r>
-                        <a:t>AEGIS Architecture (Proposed)</a:t>
-                      </a:r>
-                    </a:p>
-                  </a:txBody>
-                  <a:tcPr>
-                    <a:solidFill>
-                      <a:srgbClr val="003366"/>
-                    </a:solidFill>
-                  </a:tcPr>
-                </a:tc>
-                <a:tc>
-                  <a:txBody>
-                    <a:bodyPr/>
-                    <a:lstStyle/>
-                    <a:p>
-                      <a:pPr>
-                        <a:defRPr b="1" sz="1500">
-                          <a:solidFill>
-                            <a:srgbClr val="FFFFFF"/>
-                          </a:solidFill>
-                        </a:defRPr>
-                      </a:pPr>
-                      <a:r>
-                        <a:t>Direct Generative LLM (Baseline)</a:t>
-                      </a:r>
-                    </a:p>
-                  </a:txBody>
-                  <a:tcPr>
-                    <a:solidFill>
-                      <a:srgbClr val="003366"/>
-                    </a:solidFill>
-                  </a:tcPr>
-                </a:tc>
-              </a:tr>
-              <a:tr h="640080">
-                <a:tc>
-                  <a:txBody>
-                    <a:bodyPr/>
-                    <a:lstStyle/>
-                    <a:p>
-                      <a:pPr>
-                        <a:defRPr sz="1500"/>
-                      </a:pPr>
-                      <a:r>
-                        <a:t>Unsafe Query Rate (Security)</a:t>
-                      </a:r>
-                    </a:p>
-                  </a:txBody>
-                  <a:tcPr/>
-                </a:tc>
-                <a:tc>
-                  <a:txBody>
-                    <a:bodyPr/>
-                    <a:lstStyle/>
-                    <a:p>
-                      <a:pPr>
-                        <a:defRPr sz="1500"/>
-                      </a:pPr>
-                      <a:r>
-                        <a:t>0.0% (Safe)</a:t>
-                      </a:r>
-                    </a:p>
-                  </a:txBody>
-                  <a:tcPr/>
-                </a:tc>
-                <a:tc>
-                  <a:txBody>
-                    <a:bodyPr/>
-                    <a:lstStyle/>
-                    <a:p>
-                      <a:pPr>
-                        <a:defRPr sz="1500"/>
-                      </a:pPr>
-                      <a:r>
-                        <a:t>5.0% (Vulnerable)</a:t>
-                      </a:r>
-                    </a:p>
-                  </a:txBody>
-                  <a:tcPr/>
-                </a:tc>
-              </a:tr>
-              <a:tr h="640080">
-                <a:tc>
-                  <a:txBody>
-                    <a:bodyPr/>
-                    <a:lstStyle/>
-                    <a:p>
-                      <a:pPr>
-                        <a:defRPr sz="1500"/>
-                      </a:pPr>
-                      <a:r>
-                        <a:t>Execution Validity (Accuracy)</a:t>
-                      </a:r>
-                    </a:p>
-                  </a:txBody>
-                  <a:tcPr/>
-                </a:tc>
-                <a:tc>
-                  <a:txBody>
-                    <a:bodyPr/>
-                    <a:lstStyle/>
-                    <a:p>
-                      <a:pPr>
-                        <a:defRPr sz="1500"/>
-                      </a:pPr>
-                      <a:r>
-                        <a:t>100.0%</a:t>
-                      </a:r>
-                    </a:p>
-                  </a:txBody>
-                  <a:tcPr/>
-                </a:tc>
-                <a:tc>
-                  <a:txBody>
-                    <a:bodyPr/>
-                    <a:lstStyle/>
-                    <a:p>
-                      <a:pPr>
-                        <a:defRPr sz="1500"/>
-                      </a:pPr>
-                      <a:r>
-                        <a:t>64.7%</a:t>
-                      </a:r>
-                    </a:p>
-                  </a:txBody>
-                  <a:tcPr/>
-                </a:tc>
-              </a:tr>
-              <a:tr h="640080">
-                <a:tc>
-                  <a:txBody>
-                    <a:bodyPr/>
-                    <a:lstStyle/>
-                    <a:p>
-                      <a:pPr>
-                        <a:defRPr sz="1500"/>
-                      </a:pPr>
-                      <a:r>
-                        <a:t>Term Coverage Accuracy</a:t>
-                      </a:r>
-                    </a:p>
-                  </a:txBody>
-                  <a:tcPr/>
-                </a:tc>
-                <a:tc>
-                  <a:txBody>
-                    <a:bodyPr/>
-                    <a:lstStyle/>
-                    <a:p>
-                      <a:pPr>
-                        <a:defRPr sz="1500"/>
-                      </a:pPr>
-                      <a:r>
-                        <a:t>100.0%</a:t>
-                      </a:r>
-                    </a:p>
-                  </a:txBody>
-                  <a:tcPr/>
-                </a:tc>
-                <a:tc>
-                  <a:txBody>
-                    <a:bodyPr/>
-                    <a:lstStyle/>
-                    <a:p>
-                      <a:pPr>
-                        <a:defRPr sz="1500"/>
-                      </a:pPr>
-                      <a:r>
-                        <a:t>85.0%</a:t>
-                      </a:r>
-                    </a:p>
-                  </a:txBody>
-                  <a:tcPr/>
-                </a:tc>
-              </a:tr>
-            </a:tbl>
-          </a:graphicData>
-        </a:graphic>
-      </p:graphicFrame>
-      <p:sp>
-        <p:nvSpPr>
-          <p:cNvPr id="14" name="TextBox 13"/>
+      <p:sp>
+        <p:nvSpPr>
+          <p:cNvPr id="13" name="TextBox 12"/>
           <p:cNvSpPr txBox="1"/>
           <p:nvPr/>
         </p:nvSpPr>
         <p:spPr>
           <a:xfrm>
-            <a:off x="1371600" y="4572000"/>
-            <a:ext cx="9418320" cy="457200"/>
+            <a:off x="1097280" y="1645920"/>
+            <a:ext cx="10058400" cy="4114800"/>
           </a:xfrm>
           <a:prstGeom prst="rect">
             <a:avLst/>
@@ -8092,14 +8593,104 @@
           <a:lstStyle/>
           <a:p>
             <a:pPr>
-              <a:defRPr sz="1300" i="1">
+              <a:defRPr sz="1800">
                 <a:solidFill>
-                  <a:srgbClr val="646464"/>
+                  <a:srgbClr val="333333"/>
                 </a:solidFill>
               </a:defRPr>
             </a:pPr>
             <a:r>
-              <a:t>*Note: Preliminary evaluation observations based on initial benchmark runs over 100 test queries.</a:t>
+              <a:t>Current Scope Boundaries:</a:t>
+            </a:r>
+          </a:p>
+          <a:p>
+            <a:pPr>
+              <a:defRPr sz="1800">
+                <a:solidFill>
+                  <a:srgbClr val="333333"/>
+                </a:solidFill>
+              </a:defRPr>
+            </a:pPr>
+            <a:r>
+              <a:t>• Closed Vocabulary Constraint:</a:t>
+            </a:r>
+          </a:p>
+          <a:p>
+            <a:pPr>
+              <a:defRPr sz="1800">
+                <a:solidFill>
+                  <a:srgbClr val="333333"/>
+                </a:solidFill>
+              </a:defRPr>
+            </a:pPr>
+            <a:r>
+              <a:t>  Queries requiring un-mapped custom metrics or free-form SQL functions cannot be compiled without schema registry updates.</a:t>
+            </a:r>
+          </a:p>
+          <a:p>
+            <a:pPr>
+              <a:defRPr sz="1800">
+                <a:solidFill>
+                  <a:srgbClr val="333333"/>
+                </a:solidFill>
+              </a:defRPr>
+            </a:pPr>
+          </a:p>
+          <a:p>
+            <a:pPr>
+              <a:defRPr sz="1800">
+                <a:solidFill>
+                  <a:srgbClr val="333333"/>
+                </a:solidFill>
+              </a:defRPr>
+            </a:pPr>
+            <a:r>
+              <a:t>• Single-Database Target Architecture:</a:t>
+            </a:r>
+          </a:p>
+          <a:p>
+            <a:pPr>
+              <a:defRPr sz="1800">
+                <a:solidFill>
+                  <a:srgbClr val="333333"/>
+                </a:solidFill>
+              </a:defRPr>
+            </a:pPr>
+            <a:r>
+              <a:t>  Designed and evaluated on relational DBMS architectures (PostgreSQL/SQL Server).</a:t>
+            </a:r>
+          </a:p>
+          <a:p>
+            <a:pPr>
+              <a:defRPr sz="1800">
+                <a:solidFill>
+                  <a:srgbClr val="333333"/>
+                </a:solidFill>
+              </a:defRPr>
+            </a:pPr>
+          </a:p>
+          <a:p>
+            <a:pPr>
+              <a:defRPr sz="1800">
+                <a:solidFill>
+                  <a:srgbClr val="333333"/>
+                </a:solidFill>
+              </a:defRPr>
+            </a:pPr>
+            <a:r>
+              <a:t>Recognized Methodological Trade-Off:</a:t>
+            </a:r>
+          </a:p>
+          <a:p>
+            <a:pPr>
+              <a:defRPr sz="1800">
+                <a:solidFill>
+                  <a:srgbClr val="333333"/>
+                </a:solidFill>
+              </a:defRPr>
+            </a:pPr>
+            <a:r>
+              <a:t>• Trading unconstrained natural language SQL generation for provable execution safety and database governance.</a:t>
             </a:r>
           </a:p>
         </p:txBody>
@@ -8112,7 +8703,7 @@
 </p:sld>
 </file>
 
-<file path=ppt/slides/slide16.xml><?xml version="1.0" encoding="utf-8"?>
+<file path=ppt/slides/slide17.xml><?xml version="1.0" encoding="utf-8"?>
 <p:sld xmlns:a="http://schemas.openxmlformats.org/drawingml/2006/main" xmlns:p="http://schemas.openxmlformats.org/presentationml/2006/main" xmlns:r="http://schemas.openxmlformats.org/officeDocument/2006/relationships">
   <p:cSld>
     <p:spTree>
@@ -8341,7 +8932,7 @@
               </a:defRPr>
             </a:pPr>
             <a:r>
-              <a:t>System Scope &amp; Limitations</a:t>
+              <a:t>Future Research Plan &amp; Thesis Roadmap</a:t>
             </a:r>
           </a:p>
         </p:txBody>
@@ -8400,7 +8991,7 @@
               </a:defRPr>
             </a:pPr>
             <a:r>
-              <a:t>Current Scope Boundaries:</a:t>
+              <a:t>Remaining Research Milestones:</a:t>
             </a:r>
           </a:p>
           <a:p>
@@ -8411,9 +9002,6 @@
                 </a:solidFill>
               </a:defRPr>
             </a:pPr>
-            <a:r>
-              <a:t>• Closed Vocabulary Constraint:</a:t>
-            </a:r>
           </a:p>
           <a:p>
             <a:pPr>
@@ -8424,7 +9012,7 @@
               </a:defRPr>
             </a:pPr>
             <a:r>
-              <a:t>  Queries requiring un-mapped custom metrics or free-form SQL functions cannot be compiled without schema registry updates.</a:t>
+              <a:t>1. Complete Benchmark Evaluation:</a:t>
             </a:r>
           </a:p>
           <a:p>
@@ -8435,6 +9023,9 @@
                 </a:solidFill>
               </a:defRPr>
             </a:pPr>
+            <a:r>
+              <a:t>   Finalizing comprehensive testing across all 100 test queries and 20 injection cases.</a:t>
+            </a:r>
           </a:p>
           <a:p>
             <a:pPr>
@@ -8444,9 +9035,6 @@
                 </a:solidFill>
               </a:defRPr>
             </a:pPr>
-            <a:r>
-              <a:t>• Single-Database Target Architecture:</a:t>
-            </a:r>
           </a:p>
           <a:p>
             <a:pPr>
@@ -8457,7 +9045,7 @@
               </a:defRPr>
             </a:pPr>
             <a:r>
-              <a:t>  Designed and evaluated on relational DBMS architectures (PostgreSQL/SQL Server).</a:t>
+              <a:t>2. Advanced Compiler Primitives:</a:t>
             </a:r>
           </a:p>
           <a:p>
@@ -8468,6 +9056,9 @@
                 </a:solidFill>
               </a:defRPr>
             </a:pPr>
+            <a:r>
+              <a:t>   Extending the AST compiler to support complex SQL window functions (PARTITION BY, LEAD/LAG).</a:t>
+            </a:r>
           </a:p>
           <a:p>
             <a:pPr>
@@ -8477,9 +9068,6 @@
                 </a:solidFill>
               </a:defRPr>
             </a:pPr>
-            <a:r>
-              <a:t>Recognized Methodological Trade-Off:</a:t>
-            </a:r>
           </a:p>
           <a:p>
             <a:pPr>
@@ -8490,298 +9078,9 @@
               </a:defRPr>
             </a:pPr>
             <a:r>
-              <a:t>• Trading unconstrained natural language SQL generation for provable execution safety and database governance.</a:t>
-            </a:r>
-          </a:p>
-        </p:txBody>
-      </p:sp>
-    </p:spTree>
-  </p:cSld>
-  <p:clrMapOvr>
-    <a:masterClrMapping/>
-  </p:clrMapOvr>
-</p:sld>
-</file>
-
-<file path=ppt/slides/slide17.xml><?xml version="1.0" encoding="utf-8"?>
-<p:sld xmlns:a="http://schemas.openxmlformats.org/drawingml/2006/main" xmlns:p="http://schemas.openxmlformats.org/presentationml/2006/main" xmlns:r="http://schemas.openxmlformats.org/officeDocument/2006/relationships">
-  <p:cSld>
-    <p:spTree>
-      <p:nvGrpSpPr>
-        <p:cNvPr id="1" name=""/>
-        <p:cNvGrpSpPr/>
-        <p:nvPr/>
-      </p:nvGrpSpPr>
-      <p:grpSpPr/>
-      <p:sp>
-        <p:nvSpPr>
-          <p:cNvPr id="11" name="Rectangle 10">
-            <a:extLst>
-              <a:ext uri="{FF2B5EF4-FFF2-40B4-BE49-F238E27FC236}">
-                <a16:creationId xmlns:a16="http://schemas.microsoft.com/office/drawing/2014/main" id="{D059D760-A365-91EB-B942-587B657A477E}"/>
-              </a:ext>
-            </a:extLst>
-          </p:cNvPr>
-          <p:cNvSpPr/>
-          <p:nvPr/>
-        </p:nvSpPr>
-        <p:spPr>
-          <a:xfrm>
-            <a:off x="-1" y="1500807"/>
-            <a:ext cx="12191999" cy="18288"/>
-          </a:xfrm>
-          <a:prstGeom prst="rect">
-            <a:avLst/>
-          </a:prstGeom>
-          <a:gradFill flip="none" rotWithShape="1">
-            <a:gsLst>
-              <a:gs pos="0">
-                <a:schemeClr val="accent1">
-                  <a:lumMod val="40000"/>
-                  <a:lumOff val="60000"/>
-                </a:schemeClr>
-              </a:gs>
-              <a:gs pos="36000">
-                <a:schemeClr val="accent1">
-                  <a:lumMod val="95000"/>
-                  <a:lumOff val="5000"/>
-                </a:schemeClr>
-              </a:gs>
-              <a:gs pos="100000">
-                <a:schemeClr val="tx2">
-                  <a:lumMod val="50000"/>
-                </a:schemeClr>
-              </a:gs>
-            </a:gsLst>
-            <a:path path="circle">
-              <a:fillToRect l="50000" t="130000" r="50000" b="-30000"/>
-            </a:path>
-            <a:tileRect/>
-          </a:gradFill>
-          <a:ln>
-            <a:noFill/>
-          </a:ln>
-        </p:spPr>
-        <p:style>
-          <a:lnRef idx="2">
-            <a:schemeClr val="accent1">
-              <a:shade val="15000"/>
-            </a:schemeClr>
-          </a:lnRef>
-          <a:fillRef idx="1">
-            <a:schemeClr val="accent1"/>
-          </a:fillRef>
-          <a:effectRef idx="0">
-            <a:schemeClr val="accent1"/>
-          </a:effectRef>
-          <a:fontRef idx="minor">
-            <a:schemeClr val="lt1"/>
-          </a:fontRef>
-        </p:style>
-        <p:txBody>
-          <a:bodyPr rtlCol="0" anchor="ctr"/>
-          <a:lstStyle/>
-          <a:p>
-            <a:pPr algn="ctr"/>
-            <a:endParaRPr lang="en-US"/>
-          </a:p>
-        </p:txBody>
-      </p:sp>
-      <p:sp>
-        <p:nvSpPr>
-          <p:cNvPr id="7" name="Rectangle 6">
-            <a:extLst>
-              <a:ext uri="{FF2B5EF4-FFF2-40B4-BE49-F238E27FC236}">
-                <a16:creationId xmlns:a16="http://schemas.microsoft.com/office/drawing/2014/main" id="{37F49795-9FC6-D65C-AAE9-247F6DF3DA3F}"/>
-              </a:ext>
-            </a:extLst>
-          </p:cNvPr>
-          <p:cNvSpPr/>
-          <p:nvPr/>
-        </p:nvSpPr>
-        <p:spPr>
-          <a:xfrm>
-            <a:off x="0" y="6291468"/>
-            <a:ext cx="12192000" cy="586409"/>
-          </a:xfrm>
-          <a:prstGeom prst="rect">
-            <a:avLst/>
-          </a:prstGeom>
-          <a:solidFill>
-            <a:schemeClr val="tx2">
-              <a:lumMod val="75000"/>
-            </a:schemeClr>
-          </a:solidFill>
-          <a:ln>
-            <a:noFill/>
-          </a:ln>
-          <a:effectLst>
-            <a:outerShdw blurRad="63500" sx="102000" sy="102000" algn="ctr" rotWithShape="0">
-              <a:prstClr val="black">
-                <a:alpha val="40000"/>
-              </a:prstClr>
-            </a:outerShdw>
-          </a:effectLst>
-        </p:spPr>
-        <p:style>
-          <a:lnRef idx="2">
-            <a:schemeClr val="accent1">
-              <a:shade val="15000"/>
-            </a:schemeClr>
-          </a:lnRef>
-          <a:fillRef idx="1">
-            <a:schemeClr val="accent1"/>
-          </a:fillRef>
-          <a:effectRef idx="0">
-            <a:schemeClr val="accent1"/>
-          </a:effectRef>
-          <a:fontRef idx="minor">
-            <a:schemeClr val="lt1"/>
-          </a:fontRef>
-        </p:style>
-        <p:txBody>
-          <a:bodyPr rtlCol="0" anchor="ctr"/>
-          <a:lstStyle/>
-          <a:p>
-            <a:pPr algn="ctr"/>
-            <a:endParaRPr lang="en-US" dirty="0"/>
-          </a:p>
-        </p:txBody>
-      </p:sp>
-      <p:sp>
-        <p:nvSpPr>
-          <p:cNvPr id="3" name="Rectangle 2">
-            <a:extLst>
-              <a:ext uri="{FF2B5EF4-FFF2-40B4-BE49-F238E27FC236}">
-                <a16:creationId xmlns:a16="http://schemas.microsoft.com/office/drawing/2014/main" id="{6027AE48-C47C-33FE-8F56-0AA4260C9B62}"/>
-              </a:ext>
-            </a:extLst>
-          </p:cNvPr>
-          <p:cNvSpPr/>
-          <p:nvPr/>
-        </p:nvSpPr>
-        <p:spPr>
-          <a:xfrm>
-            <a:off x="0" y="0"/>
-            <a:ext cx="12192000" cy="1500809"/>
-          </a:xfrm>
-          <a:prstGeom prst="rect">
-            <a:avLst/>
-          </a:prstGeom>
-          <a:solidFill>
-            <a:schemeClr val="accent1">
-              <a:lumMod val="20000"/>
-              <a:lumOff val="80000"/>
-            </a:schemeClr>
-          </a:solidFill>
-          <a:ln>
-            <a:noFill/>
-          </a:ln>
-          <a:effectLst/>
-        </p:spPr>
-        <p:style>
-          <a:lnRef idx="2">
-            <a:schemeClr val="accent1">
-              <a:shade val="15000"/>
-            </a:schemeClr>
-          </a:lnRef>
-          <a:fillRef idx="1">
-            <a:schemeClr val="accent1"/>
-          </a:fillRef>
-          <a:effectRef idx="0">
-            <a:schemeClr val="accent1"/>
-          </a:effectRef>
-          <a:fontRef idx="minor">
-            <a:schemeClr val="lt1"/>
-          </a:fontRef>
-        </p:style>
-        <p:txBody>
-          <a:bodyPr rtlCol="0" anchor="ctr"/>
-          <a:lstStyle/>
-          <a:p>
-            <a:pPr algn="ctr"/>
-            <a:endParaRPr lang="en-US" dirty="0"/>
-          </a:p>
-        </p:txBody>
-      </p:sp>
-      <p:sp>
-        <p:nvSpPr>
-          <p:cNvPr id="2" name="Title 1"/>
-          <p:cNvSpPr>
-            <a:spLocks noGrp="1"/>
-          </p:cNvSpPr>
-          <p:nvPr>
-            <p:ph type="title"/>
-          </p:nvPr>
-        </p:nvSpPr>
-        <p:spPr>
-          <a:xfrm>
-            <a:off x="1188720" y="365760"/>
-            <a:ext cx="9601200" cy="731520"/>
-          </a:xfrm>
-        </p:spPr>
-        <p:txBody>
-          <a:bodyPr/>
-          <a:lstStyle/>
-          <a:p>
-            <a:pPr>
-              <a:defRPr b="1" sz="2400">
-                <a:solidFill>
-                  <a:srgbClr val="003366"/>
-                </a:solidFill>
-              </a:defRPr>
-            </a:pPr>
-            <a:r>
-              <a:t>Future Research Plan &amp; Thesis Roadmap</a:t>
-            </a:r>
-          </a:p>
-        </p:txBody>
-      </p:sp>
-      <p:pic>
-        <p:nvPicPr>
-          <p:cNvPr id="12" name="Picture 11" descr="image.png"/>
-          <p:cNvPicPr>
-            <a:picLocks noChangeAspect="1"/>
-          </p:cNvPicPr>
-          <p:nvPr/>
-        </p:nvPicPr>
-        <p:blipFill>
-          <a:blip r:embed="rId2"/>
-          <a:stretch>
-            <a:fillRect/>
-          </a:stretch>
-        </p:blipFill>
-        <p:spPr>
-          <a:xfrm>
-            <a:off x="512874" y="457199"/>
-            <a:ext cx="592309" cy="586409"/>
-          </a:xfrm>
-          <a:prstGeom prst="rect">
-            <a:avLst/>
-          </a:prstGeom>
-        </p:spPr>
-      </p:pic>
-      <p:sp>
-        <p:nvSpPr>
-          <p:cNvPr id="13" name="TextBox 12"/>
-          <p:cNvSpPr txBox="1"/>
-          <p:nvPr/>
-        </p:nvSpPr>
-        <p:spPr>
-          <a:xfrm>
-            <a:off x="1097280" y="1645920"/>
-            <a:ext cx="10058400" cy="4114800"/>
-          </a:xfrm>
-          <a:prstGeom prst="rect">
-            <a:avLst/>
-          </a:prstGeom>
-          <a:noFill/>
-        </p:spPr>
-        <p:txBody>
-          <a:bodyPr wrap="square">
-            <a:spAutoFit/>
-          </a:bodyPr>
-          <a:lstStyle/>
+              <a:t>3. Thesis Dissertation Completion:</a:t>
+            </a:r>
+          </a:p>
           <a:p>
             <a:pPr>
               <a:defRPr sz="1800">
@@ -8791,106 +9090,7 @@
               </a:defRPr>
             </a:pPr>
             <a:r>
-              <a:t>Remaining Research Milestones:</a:t>
-            </a:r>
-          </a:p>
-          <a:p>
-            <a:pPr>
-              <a:defRPr sz="1800">
-                <a:solidFill>
-                  <a:srgbClr val="333333"/>
-                </a:solidFill>
-              </a:defRPr>
-            </a:pPr>
-          </a:p>
-          <a:p>
-            <a:pPr>
-              <a:defRPr sz="1800">
-                <a:solidFill>
-                  <a:srgbClr val="333333"/>
-                </a:solidFill>
-              </a:defRPr>
-            </a:pPr>
-            <a:r>
-              <a:t>1. Expanded Benchmark Evaluation:</a:t>
-            </a:r>
-          </a:p>
-          <a:p>
-            <a:pPr>
-              <a:defRPr sz="1800">
-                <a:solidFill>
-                  <a:srgbClr val="333333"/>
-                </a:solidFill>
-              </a:defRPr>
-            </a:pPr>
-            <a:r>
-              <a:t>   Comprehensive testing across additional database schemas and edge-case query primitives.</a:t>
-            </a:r>
-          </a:p>
-          <a:p>
-            <a:pPr>
-              <a:defRPr sz="1800">
-                <a:solidFill>
-                  <a:srgbClr val="333333"/>
-                </a:solidFill>
-              </a:defRPr>
-            </a:pPr>
-          </a:p>
-          <a:p>
-            <a:pPr>
-              <a:defRPr sz="1800">
-                <a:solidFill>
-                  <a:srgbClr val="333333"/>
-                </a:solidFill>
-              </a:defRPr>
-            </a:pPr>
-            <a:r>
-              <a:t>2. Advanced Compiler Primitives:</a:t>
-            </a:r>
-          </a:p>
-          <a:p>
-            <a:pPr>
-              <a:defRPr sz="1800">
-                <a:solidFill>
-                  <a:srgbClr val="333333"/>
-                </a:solidFill>
-              </a:defRPr>
-            </a:pPr>
-            <a:r>
-              <a:t>   Extending the AST compiler to support complex SQL window functions (PARTITION BY, LEAD/LAG).</a:t>
-            </a:r>
-          </a:p>
-          <a:p>
-            <a:pPr>
-              <a:defRPr sz="1800">
-                <a:solidFill>
-                  <a:srgbClr val="333333"/>
-                </a:solidFill>
-              </a:defRPr>
-            </a:pPr>
-          </a:p>
-          <a:p>
-            <a:pPr>
-              <a:defRPr sz="1800">
-                <a:solidFill>
-                  <a:srgbClr val="333333"/>
-                </a:solidFill>
-              </a:defRPr>
-            </a:pPr>
-            <a:r>
-              <a:t>3. Thesis Dissertation Completion:</a:t>
-            </a:r>
-          </a:p>
-          <a:p>
-            <a:pPr>
-              <a:defRPr sz="1800">
-                <a:solidFill>
-                  <a:srgbClr val="333333"/>
-                </a:solidFill>
-              </a:defRPr>
-            </a:pPr>
-            <a:r>
-              <a:t>   Finalizing experimental write-ups and comparative empirical analysis for final defense.</a:t>
+              <a:t>   Finalizing experimental results, write-ups, and comparative analysis for final defense.</a:t>
             </a:r>
           </a:p>
         </p:txBody>
@@ -11381,7 +11581,7 @@
               </a:defRPr>
             </a:pPr>
             <a:r>
-              <a:t>  Can natural language analytics be performed without allowing Large Language Models to generate executable SQL code?</a:t>
+              <a:t>  Can Large Language Models support natural language analytics without generating executable SQL code?</a:t>
             </a:r>
           </a:p>
           <a:p>
@@ -11414,7 +11614,7 @@
               </a:defRPr>
             </a:pPr>
             <a:r>
-              <a:t>  Can deterministic query compilation improve database security and execution governance compared to generative baselines?</a:t>
+              <a:t>  Can deterministic query compilation improve database safety and execution governance compared to generative baselines?</a:t>
             </a:r>
           </a:p>
           <a:p>
@@ -11447,7 +11647,7 @@
               </a:defRPr>
             </a:pPr>
             <a:r>
-              <a:t>  Can closed-vocabulary semantic constraints preserve analytical expressiveness while eliminating execution risks?</a:t>
+              <a:t>  Can closed-vocabulary semantic constraints maintain analytical usefulness while reducing execution risks?</a:t>
             </a:r>
           </a:p>
         </p:txBody>
@@ -11741,7 +11941,7 @@
           <a:lstStyle/>
           <a:p>
             <a:pPr>
-              <a:defRPr sz="1700">
+              <a:defRPr sz="1600">
                 <a:solidFill>
                   <a:srgbClr val="333333"/>
                 </a:solidFill>
@@ -11753,7 +11953,7 @@
           </a:p>
           <a:p>
             <a:pPr>
-              <a:defRPr sz="1700">
+              <a:defRPr sz="1600">
                 <a:solidFill>
                   <a:srgbClr val="333333"/>
                 </a:solidFill>
@@ -11765,7 +11965,7 @@
           </a:p>
           <a:p>
             <a:pPr>
-              <a:defRPr sz="1700">
+              <a:defRPr sz="1600">
                 <a:solidFill>
                   <a:srgbClr val="333333"/>
                 </a:solidFill>
@@ -11774,7 +11974,7 @@
           </a:p>
           <a:p>
             <a:pPr>
-              <a:defRPr sz="1700">
+              <a:defRPr sz="1600">
                 <a:solidFill>
                   <a:srgbClr val="333333"/>
                 </a:solidFill>
@@ -11786,7 +11986,7 @@
           </a:p>
           <a:p>
             <a:pPr>
-              <a:defRPr sz="1700">
+              <a:defRPr sz="1600">
                 <a:solidFill>
                   <a:srgbClr val="333333"/>
                 </a:solidFill>
@@ -11798,7 +11998,7 @@
           </a:p>
           <a:p>
             <a:pPr>
-              <a:defRPr sz="1700">
+              <a:defRPr sz="1600">
                 <a:solidFill>
                   <a:srgbClr val="333333"/>
                 </a:solidFill>
@@ -11810,19 +12010,19 @@
           </a:p>
           <a:p>
             <a:pPr>
-              <a:defRPr sz="1700">
+              <a:defRPr sz="1600">
                 <a:solidFill>
                   <a:srgbClr val="333333"/>
                 </a:solidFill>
               </a:defRPr>
             </a:pPr>
             <a:r>
-              <a:t>3. Dual-Layer Verification Architecture: Structural prevention of SQL injection via static AST scanning.</a:t>
+              <a:t>3. Dual-Layer Verification Architecture: Structural prevention of unsafe SQL execution via static AST scanning.</a:t>
             </a:r>
           </a:p>
           <a:p>
             <a:pPr>
-              <a:defRPr sz="1700">
+              <a:defRPr sz="1600">
                 <a:solidFill>
                   <a:srgbClr val="333333"/>
                 </a:solidFill>
@@ -12123,7 +12323,7 @@
           <a:lstStyle/>
           <a:p>
             <a:pPr>
-              <a:defRPr sz="1700">
+              <a:defRPr sz="1600">
                 <a:solidFill>
                   <a:srgbClr val="333333"/>
                 </a:solidFill>
@@ -12135,7 +12335,7 @@
           </a:p>
           <a:p>
             <a:pPr>
-              <a:defRPr sz="1700">
+              <a:defRPr sz="1600">
                 <a:solidFill>
                   <a:srgbClr val="333333"/>
                 </a:solidFill>
@@ -12144,7 +12344,7 @@
           </a:p>
           <a:p>
             <a:pPr>
-              <a:defRPr sz="1700">
+              <a:defRPr sz="1600">
                 <a:solidFill>
                   <a:srgbClr val="333333"/>
                 </a:solidFill>
@@ -12156,7 +12356,7 @@
           </a:p>
           <a:p>
             <a:pPr>
-              <a:defRPr sz="1700">
+              <a:defRPr sz="1600">
                 <a:solidFill>
                   <a:srgbClr val="333333"/>
                 </a:solidFill>
@@ -12168,7 +12368,7 @@
           </a:p>
           <a:p>
             <a:pPr>
-              <a:defRPr sz="1700">
+              <a:defRPr sz="1600">
                 <a:solidFill>
                   <a:srgbClr val="333333"/>
                 </a:solidFill>
@@ -12177,7 +12377,7 @@
           </a:p>
           <a:p>
             <a:pPr>
-              <a:defRPr sz="1700">
+              <a:defRPr sz="1600">
                 <a:solidFill>
                   <a:srgbClr val="333333"/>
                 </a:solidFill>
@@ -12189,7 +12389,7 @@
           </a:p>
           <a:p>
             <a:pPr>
-              <a:defRPr sz="1700">
+              <a:defRPr sz="1600">
                 <a:solidFill>
                   <a:srgbClr val="333333"/>
                 </a:solidFill>
@@ -12201,14 +12401,14 @@
           </a:p>
           <a:p>
             <a:pPr>
-              <a:defRPr sz="1700">
+              <a:defRPr sz="1600">
                 <a:solidFill>
                   <a:srgbClr val="333333"/>
                 </a:solidFill>
               </a:defRPr>
             </a:pPr>
             <a:r>
-              <a:t>• Architectural Invariant: The neural model never generates, observes, or manipulates raw executable SQL.</a:t>
+              <a:t>• Central Research Argument: Most NL-to-SQL systems try to make LLMs generate better SQL; AEGIS redefines the problem by removing SQL generation responsibility from the LLM.</a:t>
             </a:r>
           </a:p>
         </p:txBody>

</xml_diff>

<commit_message>
fix(presentation): reframe semantic layer & demo slides as research, not project
Two slides read like a software feature list rather than a thesis
contribution:

- Semantic layer slide led with "15 metrics, 34 dimensions, 11 join
  paths across 12 of 126 tables" as a headline coverage stat - sounds
  like justifying a product's limited scope. Reframed to lead with
  the actual research contribution (a bounded, auditable vocabulary
  that replaces direct schema access) and moved the concrete
  implementation numbers to speaker notes only, for use if the
  committee asks.
- "Implementation Progress: Intent Extraction Demo" was titled and
  framed as a software demo. Retitled to "Worked Example: Tracing a
  Query Through the Pipeline" and reframed the notes to present it as
  illustrating the formal no-SQL-generation claim, not showcasing
  prototype progress.

Swept the rest of the deck for similar phrasing; no other slides had it.
</commit_message>
<xml_diff>
--- a/docs/scripts/Md_Riaz_Mid_Defense_Final_0322310105101024.pptx
+++ b/docs/scripts/Md_Riaz_Mid_Defense_Final_0322310105101024.pptx
@@ -597,7 +597,7 @@
           <a:lstStyle/>
           <a:p>
             <a:r>
-              <a:t>AEGIS introduces a Closed-Vocabulary Semantic Layer. Instead of exposing raw database schemas, the model interacts only with pre-approved metrics and dimensions. Unexposed tables and system metadata remain completely isolated. Concretely: 15 metrics, 34 dimensions, and 11 join paths cover 12 of the 126 tables in the nopCommerce schema - the other 114 (logs, CMS, permissions, vendor data) are simply invisible to the model, which is implicit table-level access control built into the architecture.</a:t>
+              <a:t>This is the core theoretical contribution: a finite registry of approved metrics and dimensions that bounds every reachable query to a Cartesian product of the two, rather than an unconstrained SQL string. If the committee asks for concrete numbers: the current nopCommerce prototype instantiates this model with 15 metrics and 34 dimensions across 11 join paths, touching 12 of the schema's 126 tables - the other 114 are system, CMS, and permission tables with no analytics relevance, so their exclusion isn't a coverage limitation, it is the access-control mechanism itself, working exactly as the formal model predicts.</a:t>
             </a:r>
           </a:p>
         </p:txBody>
@@ -877,7 +877,7 @@
           <a:lstStyle/>
           <a:p>
             <a:r>
-              <a:t>In our current prototype progress, intent extraction successfully maps user queries into bounded JSON structures. Notice that raw SQL keywords like SELECT, FROM, or WHERE are completely absent from the AI's output - the compiler assembles the SQL afterward from pre-written expressions, so the LLM's own words never touch the query string.</a:t>
+              <a:t>This trace illustrates the formal claim from the architecture section directly: the LLM's output is a bounded intent object, and the SQL string is assembled afterward from pre-written expressions - the model's own words never appear in the query. Notice that raw SQL keywords like SELECT, FROM, or WHERE are completely absent from the AI's output. An adversarial input such as "DROP TABLE" cannot reach the compiler because it is not a recognized metric or dimension term - it fails at the validation gate, not because the model chose to refuse it.</a:t>
             </a:r>
           </a:p>
         </p:txBody>
@@ -5810,13 +5810,22 @@
               </a:spcAft>
             </a:pPr>
             <a:r>
-              <a:rPr sz="1800" b="1">
+              <a:rPr sz="1700" b="1">
                 <a:solidFill>
                   <a:srgbClr val="003366"/>
                 </a:solidFill>
                 <a:latin typeface="Times New Roman"/>
               </a:rPr>
-              <a:t>Current Semantic Layer Coverage (nopCommerce):</a:t>
+              <a:t>The Research Contribution:</a:t>
+            </a:r>
+            <a:r>
+              <a:rPr sz="1600">
+                <a:solidFill>
+                  <a:srgbClr val="333333"/>
+                </a:solidFill>
+                <a:latin typeface="Times New Roman"/>
+              </a:rPr>
+              <a:t> A Bounded, Auditable Vocabulary</a:t>
             </a:r>
           </a:p>
           <a:p>
@@ -5832,13 +5841,13 @@
               </a:spcAft>
             </a:pPr>
             <a:r>
-              <a:rPr sz="1500">
+              <a:rPr sz="1600">
                 <a:solidFill>
                   <a:srgbClr val="333333"/>
                 </a:solidFill>
                 <a:latin typeface="Times New Roman"/>
               </a:rPr>
-              <a:t>• 15 metrics, 34 dimensions, 11 join paths across 12 of 126 schema tables.</a:t>
+              <a:t>• Two finite registries, approved metrics (M) and dimensions (D), replace direct schema access; every reachable query is a bounded (metric, dimension) pair, never an unconstrained SQL string.</a:t>
             </a:r>
           </a:p>
           <a:p>
@@ -5854,13 +5863,13 @@
               </a:spcAft>
             </a:pPr>
             <a:r>
-              <a:rPr sz="1500">
+              <a:rPr sz="1600">
                 <a:solidFill>
                   <a:srgbClr val="333333"/>
                 </a:solidFill>
                 <a:latin typeface="Times New Roman"/>
               </a:rPr>
-              <a:t>• The remaining 114 tables (system logs, CMS content, permissions, vendor data) are simply not in the model's vocabulary - implicit table-level access control by construction.</a:t>
+              <a:t>• Anything outside these registries is structurally invisible to the model - not a coverage gap, but the actual mechanism by which unauthorized access is prevented by construction.</a:t>
             </a:r>
           </a:p>
           <a:p>
@@ -5876,7 +5885,7 @@
               </a:spcAft>
             </a:pPr>
             <a:r>
-              <a:rPr sz="1800" b="1">
+              <a:rPr sz="1900" b="1">
                 <a:solidFill>
                   <a:srgbClr val="003366"/>
                 </a:solidFill>
@@ -5898,7 +5907,7 @@
               </a:spcAft>
             </a:pPr>
             <a:r>
-              <a:rPr b="1" sz="1500">
+              <a:rPr b="1" sz="1600">
                 <a:solidFill>
                   <a:srgbClr val="003366"/>
                 </a:solidFill>
@@ -5907,13 +5916,13 @@
               <a:t>• Revenue by category:</a:t>
             </a:r>
             <a:r>
-              <a:rPr sz="1500">
+              <a:rPr sz="1600">
                 <a:solidFill>
                   <a:srgbClr val="333333"/>
                 </a:solidFill>
                 <a:latin typeface="Times New Roman"/>
               </a:rPr>
-              <a:t> Order -&gt; OrderItem -&gt; Product -&gt; Category (4 joins, found by BFS over the join graph)</a:t>
+              <a:t> Order -&gt; OrderItem -&gt; Product -&gt; Category</a:t>
             </a:r>
           </a:p>
           <a:p>
@@ -5929,7 +5938,7 @@
               </a:spcAft>
             </a:pPr>
             <a:r>
-              <a:rPr b="1" sz="1500">
+              <a:rPr b="1" sz="1600">
                 <a:solidFill>
                   <a:srgbClr val="003366"/>
                 </a:solidFill>
@@ -5938,13 +5947,13 @@
               <a:t>• Revenue by country:</a:t>
             </a:r>
             <a:r>
-              <a:rPr sz="1500">
+              <a:rPr sz="1600">
                 <a:solidFill>
                   <a:srgbClr val="333333"/>
                 </a:solidFill>
                 <a:latin typeface="Times New Roman"/>
               </a:rPr>
-              <a:t> Order -&gt; Address -&gt; Country (2 joins)</a:t>
+              <a:t> Order -&gt; Address -&gt; Country</a:t>
             </a:r>
           </a:p>
           <a:p>
@@ -5960,13 +5969,13 @@
               </a:spcAft>
             </a:pPr>
             <a:r>
-              <a:rPr sz="1500">
+              <a:rPr sz="1600">
                 <a:solidFill>
                   <a:srgbClr val="333333"/>
                 </a:solidFill>
                 <a:latin typeface="Times New Roman"/>
               </a:rPr>
-              <a:t>• The developer defines relationships once; the compiler resolves the shortest path automatically.</a:t>
+              <a:t>• Table relationships are defined once; the compiler finds the shortest path for any (metric, dimension) pair automatically via graph search.</a:t>
             </a:r>
           </a:p>
           <a:p>
@@ -5982,7 +5991,7 @@
               </a:spcAft>
             </a:pPr>
             <a:r>
-              <a:rPr sz="1800" b="1">
+              <a:rPr sz="1900" b="1">
                 <a:solidFill>
                   <a:srgbClr val="003366"/>
                 </a:solidFill>
@@ -6004,13 +6013,13 @@
               </a:spcAft>
             </a:pPr>
             <a:r>
-              <a:rPr sz="1500">
+              <a:rPr sz="1600">
                 <a:solidFill>
                   <a:srgbClr val="333333"/>
                 </a:solidFill>
                 <a:latin typeface="Times New Roman"/>
               </a:rPr>
-              <a:t>• Any term requested outside the closed vocabulary is rejected by the validation parser before query compilation.</a:t>
+              <a:t>• Any term outside the closed vocabulary is rejected before query compilation - enforced by validation, not by convention.</a:t>
             </a:r>
           </a:p>
         </p:txBody>
@@ -8743,7 +8752,7 @@
               </a:defRPr>
             </a:pPr>
             <a:r>
-              <a:t>Implementation Progress: Intent Extraction Demo</a:t>
+              <a:t>Worked Example: Tracing a Query Through the Pipeline</a:t>
             </a:r>
           </a:p>
         </p:txBody>

</xml_diff>

<commit_message>
Rename "Research Background & Context" to "Introduction"
Updated slide 3's title, the outline entry on slide 2, and the
document's title-parts metadata for consistency.

Co-Authored-By: Claude Sonnet 5 <noreply@anthropic.com>
</commit_message>
<xml_diff>
--- a/docs/scripts/Md_Riaz_Mid_Defense_Final_0322310105101024.pptx
+++ b/docs/scripts/Md_Riaz_Mid_Defense_Final_0322310105101024.pptx
@@ -16529,7 +16529,7 @@
                 </a:solidFill>
                 <a:latin typeface="Times New Roman"/>
               </a:rPr>
-              <a:t>1. Research Background &amp; Context</a:t>
+              <a:t>1. Introduction</a:t>
             </a:r>
           </a:p>
           <a:p>
@@ -22135,7 +22135,7 @@
               </a:defRPr>
             </a:pPr>
             <a:r>
-              <a:t>Research Background &amp; Context</a:t>
+              <a:t>Introduction</a:t>
             </a:r>
           </a:p>
         </p:txBody>

</xml_diff>

<commit_message>
Rename Problem Statement slide, simplify vulnerability bullets, fix bare [2] citation
- Slide 4: renamed "Problem Statement & Vulnerability Types" to
  "Problem Statement"; bullets now read the actual vulnerability name
  directly ("1. Structural Injection Risk") instead of "Vulnerability
  Class I/II/III: <name>".
- Slide 2 outline and docProps title metadata updated to match.
- Fixed the one citation left with no identifying text after the
  earlier author-name/year cleanup: Lehmann et al.'s paper has no named
  system (unlike NaLIR, Spider, etc.), so stripping the author name left
  a bare "[2]". Replaced with "Semantic Layer Position Paper [2]" on
  slide 5's heading, slide 10's table, and slide 11's inline sentence
  (reworded there to avoid repeating "position paper" twice).

Co-Authored-By: Claude Sonnet 5 <noreply@anthropic.com>
</commit_message>
<xml_diff>
--- a/docs/scripts/Md_Riaz_Mid_Defense_Final_0322310105101024.pptx
+++ b/docs/scripts/Md_Riaz_Mid_Defense_Final_0322310105101024.pptx
@@ -7927,7 +7927,7 @@
                         </a:defRPr>
                       </a:pPr>
                       <a:r>
-                        <a:t>[2]</a:t>
+                        <a:t>Semantic Layer Position Paper [2]</a:t>
                       </a:r>
                     </a:p>
                   </a:txBody>
@@ -8734,7 +8734,7 @@
                 </a:solidFill>
                 <a:latin typeface="Times New Roman"/>
               </a:rPr>
-              <a:t>Only prior work [2] proposes a semantic layer, and it is a position paper with no working implementation, safety mechanism, or evaluation.</a:t>
+              <a:t>The only prior semantic-layer proposal [2] is a position paper with no working implementation, safety mechanism, or evaluation.</a:t>
             </a:r>
           </a:p>
           <a:p>
@@ -16551,7 +16551,7 @@
                 </a:solidFill>
                 <a:latin typeface="Times New Roman"/>
               </a:rPr>
-              <a:t>2. Problem Statement &amp; Vulnerability Types</a:t>
+              <a:t>2. Problem Statement</a:t>
             </a:r>
           </a:p>
           <a:p>
@@ -22647,7 +22647,7 @@
               </a:defRPr>
             </a:pPr>
             <a:r>
-              <a:t>Problem Statement &amp; Vulnerability Types</a:t>
+              <a:t>Problem Statement</a:t>
             </a:r>
           </a:p>
         </p:txBody>
@@ -22834,16 +22834,7 @@
                 </a:solidFill>
                 <a:latin typeface="Times New Roman"/>
               </a:rPr>
-              <a:t>1. Vulnerability Class I:</a:t>
-            </a:r>
-            <a:r>
-              <a:rPr sz="1600" b="0" i="0">
-                <a:solidFill>
-                  <a:srgbClr val="333333"/>
-                </a:solidFill>
-                <a:latin typeface="Times New Roman"/>
-              </a:rPr>
-              <a:t> Structural Injection Risk</a:t>
+              <a:t>1. Structural Injection Risk</a:t>
             </a:r>
           </a:p>
           <a:p>
@@ -22887,16 +22878,7 @@
                 </a:solidFill>
                 <a:latin typeface="Times New Roman"/>
               </a:rPr>
-              <a:t>2. Vulnerability Class II:</a:t>
-            </a:r>
-            <a:r>
-              <a:rPr sz="1600" b="0" i="0">
-                <a:solidFill>
-                  <a:srgbClr val="333333"/>
-                </a:solidFill>
-                <a:latin typeface="Times New Roman"/>
-              </a:rPr>
-              <a:t> Unbounded Schema Hallucination</a:t>
+              <a:t>2. Unbounded Schema Hallucination</a:t>
             </a:r>
           </a:p>
           <a:p>
@@ -22940,16 +22922,7 @@
                 </a:solidFill>
                 <a:latin typeface="Times New Roman"/>
               </a:rPr>
-              <a:t>3. Vulnerability Class III:</a:t>
-            </a:r>
-            <a:r>
-              <a:rPr sz="1600" b="0" i="0">
-                <a:solidFill>
-                  <a:srgbClr val="333333"/>
-                </a:solidFill>
-                <a:latin typeface="Times New Roman"/>
-              </a:rPr>
-              <a:t> Access Control &amp; Context Bypass</a:t>
+              <a:t>3. Access Control &amp; Context Bypass</a:t>
             </a:r>
           </a:p>
           <a:p>
@@ -23540,7 +23513,7 @@
                 </a:solidFill>
                 <a:latin typeface="Times New Roman"/>
               </a:rPr>
-              <a:t>[2]</a:t>
+              <a:t>Semantic Layer Position Paper [2]</a:t>
             </a:r>
           </a:p>
           <a:p>

</xml_diff>

<commit_message>
Center comparison table, simplify Research Questions slide, drop AI-buzzword phrasing
- Slide 10: the comparison table's frame was off-center (320040 EMU
  left margin vs. 1630680 EMU right margin) - recentered so both
  margins match.
- Slide 12: merged each "Research Question N (RQN):" bold-navy heading
  plus separate gray-italic question line into a single black,
  non-italic bullet point containing just the question, matching the
  deck's standard body style.
- Slide 13: reworded "A formal mapping restricting LLM emission space"
  to "A formal mapping that restricts the LLM's output to a closed set
  of approved metrics and dimensions" - concrete phrasing instead of
  ML-jargon.

Co-Authored-By: Claude Sonnet 5 <noreply@anthropic.com>
</commit_message>
<xml_diff>
--- a/docs/scripts/Md_Riaz_Mid_Defense_Final_0322310105101024.pptx
+++ b/docs/scripts/Md_Riaz_Mid_Defense_Final_0322310105101024.pptx
@@ -6552,7 +6552,7 @@
           <p:nvPr/>
         </p:nvGraphicFramePr>
         <p:xfrm>
-          <a:off x="320040" y="1417320"/>
+          <a:off x="975360" y="1417320"/>
           <a:ext cx="10241280" cy="4480560"/>
         </p:xfrm>
         <a:graphic>
@@ -9324,35 +9324,13 @@
               </a:spcAft>
             </a:pPr>
             <a:r>
-              <a:rPr sz="1700" b="1" i="0">
-                <a:solidFill>
-                  <a:srgbClr val="003366"/>
+              <a:rPr sz="1700" b="0" i="0">
+                <a:solidFill>
+                  <a:srgbClr val="333333"/>
                 </a:solidFill>
                 <a:latin typeface="Times New Roman"/>
               </a:rPr>
-              <a:t>• Research Question 1 (RQ1):</a:t>
-            </a:r>
-          </a:p>
-          <a:p>
-            <a:pPr marL="457200" indent="0">
-              <a:lnSpc>
-                <a:spcPct val="108000"/>
-              </a:lnSpc>
-              <a:spcBef>
-                <a:spcPts val="0"/>
-              </a:spcBef>
-              <a:spcAft>
-                <a:spcPts val="800"/>
-              </a:spcAft>
-            </a:pPr>
-            <a:r>
-              <a:rPr sz="1500" b="0" i="1">
-                <a:solidFill>
-                  <a:srgbClr val="5F5F5F"/>
-                </a:solidFill>
-                <a:latin typeface="Times New Roman"/>
-              </a:rPr>
-              <a:t>Can Large Language Models support natural language analytics without generating executable SQL code?</a:t>
+              <a:t>• Can Large Language Models support natural language analytics without generating executable SQL code?</a:t>
             </a:r>
           </a:p>
           <a:p>
@@ -9368,35 +9346,13 @@
               </a:spcAft>
             </a:pPr>
             <a:r>
-              <a:rPr sz="1700" b="1" i="0">
-                <a:solidFill>
-                  <a:srgbClr val="003366"/>
+              <a:rPr sz="1700" b="0" i="0">
+                <a:solidFill>
+                  <a:srgbClr val="333333"/>
                 </a:solidFill>
                 <a:latin typeface="Times New Roman"/>
               </a:rPr>
-              <a:t>• Research Question 2 (RQ2):</a:t>
-            </a:r>
-          </a:p>
-          <a:p>
-            <a:pPr marL="457200" indent="0">
-              <a:lnSpc>
-                <a:spcPct val="108000"/>
-              </a:lnSpc>
-              <a:spcBef>
-                <a:spcPts val="0"/>
-              </a:spcBef>
-              <a:spcAft>
-                <a:spcPts val="800"/>
-              </a:spcAft>
-            </a:pPr>
-            <a:r>
-              <a:rPr sz="1500" b="0" i="1">
-                <a:solidFill>
-                  <a:srgbClr val="5F5F5F"/>
-                </a:solidFill>
-                <a:latin typeface="Times New Roman"/>
-              </a:rPr>
-              <a:t>Can deterministic query compilation improve database safety and control compared to generative baselines?</a:t>
+              <a:t>• Can deterministic query compilation improve database safety and control compared to generative baselines?</a:t>
             </a:r>
           </a:p>
           <a:p>
@@ -9412,35 +9368,13 @@
               </a:spcAft>
             </a:pPr>
             <a:r>
-              <a:rPr sz="1700" b="1" i="0">
-                <a:solidFill>
-                  <a:srgbClr val="003366"/>
+              <a:rPr sz="1700" b="0" i="0">
+                <a:solidFill>
+                  <a:srgbClr val="333333"/>
                 </a:solidFill>
                 <a:latin typeface="Times New Roman"/>
               </a:rPr>
-              <a:t>• Research Question 3 (RQ3):</a:t>
-            </a:r>
-          </a:p>
-          <a:p>
-            <a:pPr marL="457200" indent="0">
-              <a:lnSpc>
-                <a:spcPct val="108000"/>
-              </a:lnSpc>
-              <a:spcBef>
-                <a:spcPts val="0"/>
-              </a:spcBef>
-              <a:spcAft>
-                <a:spcPts val="800"/>
-              </a:spcAft>
-            </a:pPr>
-            <a:r>
-              <a:rPr sz="1500" b="0" i="1">
-                <a:solidFill>
-                  <a:srgbClr val="5F5F5F"/>
-                </a:solidFill>
-                <a:latin typeface="Times New Roman"/>
-              </a:rPr>
-              <a:t>Can closed-vocabulary semantic constraints maintain analytical usefulness while reducing execution risks?</a:t>
+              <a:t>• Can closed-vocabulary semantic constraints maintain analytical usefulness while reducing execution risks?</a:t>
             </a:r>
           </a:p>
         </p:txBody>
@@ -9930,7 +9864,7 @@
                 </a:solidFill>
                 <a:latin typeface="Times New Roman"/>
               </a:rPr>
-              <a:t> A formal mapping restricting LLM emission space.</a:t>
+              <a:t> A formal mapping that restricts the LLM’s output to a closed set of approved metrics and dimensions.</a:t>
             </a:r>
           </a:p>
           <a:p>

</xml_diff>

<commit_message>
Revert Lehmann et al. citation label to author name instead of invented paraphrase
"Semantic Layer Position Paper [2]" was a label I invented that doesn't
appear in the actual paper. "Lehmann et al. [2]" is the better choice:
unlike the other 8 references (which had a real system name to fall
back on after removing the redundant author+year), this position paper
has no named system, so the author name isn't redundant - it's the
standard, minimal identifier, and it ties directly to the References
slide's citation. Applied consistently on slides 5, 10, and 11.

Co-Authored-By: Claude Sonnet 5 <noreply@anthropic.com>
</commit_message>
<xml_diff>
--- a/docs/scripts/Md_Riaz_Mid_Defense_Final_0322310105101024.pptx
+++ b/docs/scripts/Md_Riaz_Mid_Defense_Final_0322310105101024.pptx
@@ -7927,7 +7927,7 @@
                         </a:defRPr>
                       </a:pPr>
                       <a:r>
-                        <a:t>Semantic Layer Position Paper [2]</a:t>
+                        <a:t>Lehmann et al. [2]</a:t>
                       </a:r>
                     </a:p>
                   </a:txBody>
@@ -8734,7 +8734,7 @@
                 </a:solidFill>
                 <a:latin typeface="Times New Roman"/>
               </a:rPr>
-              <a:t>The only prior semantic-layer proposal [2] is a position paper with no working implementation, safety mechanism, or evaluation.</a:t>
+              <a:t>Only Lehmann et al. [2] proposes a semantic layer, and it is a position paper with no working implementation, safety mechanism, or evaluation.</a:t>
             </a:r>
           </a:p>
           <a:p>
@@ -23447,7 +23447,7 @@
                 </a:solidFill>
                 <a:latin typeface="Times New Roman"/>
               </a:rPr>
-              <a:t>Semantic Layer Position Paper [2]</a:t>
+              <a:t>Lehmann et al. [2]</a:t>
             </a:r>
           </a:p>
           <a:p>

</xml_diff>

<commit_message>
Slide 4: de-italicize and darken vulnerability descriptions; slide 23: black text + hyphen bullets
- Slide 4: the 3 gray italic explanation lines under each vulnerability
  class are now regular (non-italic) black text (5F5F5F -> 333333),
  matching the deck's standard body style.
- Slide 23: the 5 gray italic beneficiary-impact lines changed to
  black (5F5F5F -> 333333) with a leading hyphen on each; also caught
  and fixed a second "emission space" AI-buzzword occurrence in the
  Researchers & Students line that was missed when slide 13 was fixed
  earlier - reworded to "restrict what the model can output instead of
  policing it after the fact".

Co-Authored-By: Claude Sonnet 5 <noreply@anthropic.com>
</commit_message>
<xml_diff>
--- a/docs/scripts/Md_Riaz_Mid_Defense_Final_0322310105101024.pptx
+++ b/docs/scripts/Md_Riaz_Mid_Defense_Final_0322310105101024.pptx
@@ -19477,11 +19477,11 @@
             <a:r>
               <a:rPr sz="1350" b="0" i="1">
                 <a:solidFill>
-                  <a:srgbClr val="5F5F5F"/>
+                  <a:srgbClr val="333333"/>
                 </a:solidFill>
                 <a:latin typeface="Times New Roman"/>
               </a:rPr>
-              <a:t>Can obtain reports by describing them in plain English, without writing SQL or waiting on a developer queue.</a:t>
+              <a:t>- Can obtain reports by describing them in plain English, without writing SQL or waiting on a developer queue.</a:t>
             </a:r>
           </a:p>
           <a:p>
@@ -19521,11 +19521,11 @@
             <a:r>
               <a:rPr sz="1350" b="0" i="1">
                 <a:solidFill>
-                  <a:srgbClr val="5F5F5F"/>
+                  <a:srgbClr val="333333"/>
                 </a:solidFill>
                 <a:latin typeface="Times New Roman"/>
               </a:rPr>
-              <a:t>The auditable surface becomes a finite registry of 15 metrics and 34 dimensions, rather than an open-ended stream of model-authored SQL that must be inspected query by query.</a:t>
+              <a:t>- The auditable surface becomes a finite registry of 15 metrics and 34 dimensions, rather than an open-ended stream of model-authored SQL that must be inspected query by query.</a:t>
             </a:r>
           </a:p>
           <a:p>
@@ -19565,11 +19565,11 @@
             <a:r>
               <a:rPr sz="1350" b="0" i="1">
                 <a:solidFill>
-                  <a:srgbClr val="5F5F5F"/>
+                  <a:srgbClr val="333333"/>
                 </a:solidFill>
                 <a:latin typeface="Times New Roman"/>
               </a:rPr>
-              <a:t>Metric definitions are enforced centrally by the semantic layer, so the same business term yields the same number for every user, every time.</a:t>
+              <a:t>- Metric definitions are enforced centrally by the semantic layer, so the same business term yields the same number for every user, every time.</a:t>
             </a:r>
           </a:p>
           <a:p>
@@ -19609,11 +19609,11 @@
             <a:r>
               <a:rPr sz="1350" b="0" i="1">
                 <a:solidFill>
-                  <a:srgbClr val="5F5F5F"/>
+                  <a:srgbClr val="333333"/>
                 </a:solidFill>
                 <a:latin typeface="Times New Roman"/>
               </a:rPr>
-              <a:t>A reusable architectural pattern - constrain the model's emission space instead of policing its output - plus an open semantic layer specification and benchmark to build on.</a:t>
+              <a:t>- A reusable architectural pattern - restrict what the model can output instead of policing it after the fact - plus an open semantic layer specification and benchmark to build on.</a:t>
             </a:r>
           </a:p>
           <a:p>
@@ -19653,11 +19653,11 @@
             <a:r>
               <a:rPr sz="1350" b="0" i="1">
                 <a:solidFill>
-                  <a:srgbClr val="5F5F5F"/>
+                  <a:srgbClr val="333333"/>
                 </a:solidFill>
                 <a:latin typeface="Times New Roman"/>
               </a:rPr>
-              <a:t>A deployable path to natural language analytics that satisfies least-privilege and audit requirements in regulated environments.</a:t>
+              <a:t>- A deployable path to natural language analytics that satisfies least-privilege and audit requirements in regulated environments.</a:t>
             </a:r>
           </a:p>
         </p:txBody>
@@ -22784,9 +22784,9 @@
               </a:spcAft>
             </a:pPr>
             <a:r>
-              <a:rPr sz="1400" b="0" i="1">
-                <a:solidFill>
-                  <a:srgbClr val="5F5F5F"/>
+              <a:rPr sz="1400" b="0" i="0">
+                <a:solidFill>
+                  <a:srgbClr val="333333"/>
                 </a:solidFill>
                 <a:latin typeface="Times New Roman"/>
               </a:rPr>
@@ -22828,9 +22828,9 @@
               </a:spcAft>
             </a:pPr>
             <a:r>
-              <a:rPr sz="1400" b="0" i="1">
-                <a:solidFill>
-                  <a:srgbClr val="5F5F5F"/>
+              <a:rPr sz="1400" b="0" i="0">
+                <a:solidFill>
+                  <a:srgbClr val="333333"/>
                 </a:solidFill>
                 <a:latin typeface="Times New Roman"/>
               </a:rPr>
@@ -22872,9 +22872,9 @@
               </a:spcAft>
             </a:pPr>
             <a:r>
-              <a:rPr sz="1400" b="0" i="1">
-                <a:solidFill>
-                  <a:srgbClr val="5F5F5F"/>
+              <a:rPr sz="1400" b="0" i="0">
+                <a:solidFill>
+                  <a:srgbClr val="333333"/>
                 </a:solidFill>
                 <a:latin typeface="Times New Roman"/>
               </a:rPr>

</xml_diff>

<commit_message>
fix(presentation): merge G-SQL/TriSQL into table, fix progress overclaim, remove AI-tell dashes
- Merged G-SQL/TriSQL into the Seq2SQL comparison-table row instead of adding
  new rows; both share its capability profile (NL parsing only, no semantic
  layer, no safe-SQL guarantee, benchmark-only evaluation).
- Slide 19 claimed Experimental Evaluation & Benchmarking was 100% complete
  while slide 22 shows only 2 of 4 planned metrics measured and slide 21
  discloses only the B1 baseline has been run against AEGIS. Corrected to 60%
  with an artifact description naming exactly what's done vs. outstanding.
- Removed "(see notes)" pointers from visible slide text: speaker notes are
  private to the presenter (Presenter View only), so a slide cueing the
  audience to notes they can't see is misleading rather than helpful.
- Removed every em-dash and stray en-dash from slide content, tables, and
  notes (a recurring AI-generated-text tell), replacing with plain hyphens.
</commit_message>
<xml_diff>
--- a/docs/scripts/Md_Riaz_Mid_Defense_Final_0322310105101024.pptx
+++ b/docs/scripts/Md_Riaz_Mid_Defense_Final_0322310105101024.pptx
@@ -605,7 +605,7 @@
           <a:lstStyle/>
           <a:p>
             <a:r>
-              <a:t>The previous slide focused narrowly on text-to-SQL. This one widens the lens to the full related-work landscape I reviewed for the thesis - natural language database interfaces, text-to-SQL, natural language visualization, dashboard generation, and semantic layers - scored across seven properties. Full citations for every system are on my references slide at the end, matching the bracketed numbers in this table. Reading down the table: the classic text-to-SQL systems - Spider, BIRD, Seq2SQL, RAT-SQL, PICARD, and NaLIR, an early interactive natural-language-to-SQL interface - all handle NL parsing and nothing else. nl4dv, a toolkit that turns natural language questions into chart specifications, adds visualization. DashBot, which uses reinforcement learning to compose dashboards, adds dashboard composition with partial widget persistence. Lehmann et al. is the one paper that proposes a semantic layer, but it's a position paper with no working implementation or evaluation. And AEGIS, in the last row, is the only system with a checkmark in every column, and the only one evaluated on a production schema rather than a benchmark, an in-memory dataset, or synthetic data. That's the gap this thesis is built to close.</a:t>
+              <a:t>The previous slide focused narrowly on text-to-SQL. This one widens the lens to the full related-work landscape I reviewed for the thesis - natural language database interfaces, text-to-SQL, natural language visualization, dashboard generation, and semantic layers - scored across seven properties. Full citations for every system are on my references slide at the end, matching the bracketed numbers in this table. Reading down the table: the classic text-to-SQL systems - Spider, BIRD, Seq2SQL, G-SQL, and TriSQL - all handle NL parsing and nothing else, and NaLIR, an early interactive natural-language-to-SQL interface, was evaluated with a real user study but is otherwise the same profile. RAT-SQL and PICARD get partial credit for constraining SQL to valid grammar and schema-scoped entities. nl4dv, a toolkit that turns natural language questions into chart specifications, adds visualization. DashBot, which uses reinforcement learning to compose dashboards, adds dashboard composition with partial widget persistence, evaluated on real public Vega datasets. Veezoo, from Lehmann et al., is the one system that actually has a working semantic layer - a commercial product with an editable Knowledge Graph - but purely for usability, not safety. And AEGIS, in the last row, is the only system with a checkmark in every column, and the only one evaluated on a production schema rather than a benchmark, an in-memory dataset, or a public example dataset. That is the gap this thesis is built to close.</a:t>
             </a:r>
           </a:p>
         </p:txBody>
@@ -1235,7 +1235,7 @@
           <a:lstStyle/>
           <a:p>
             <a:r>
-              <a:t>This is where I actually stand right now. Literature review, problem definition, and the conceptual architecture design are all complete. The semantic layer specification is 80% done. Prototype and compiler implementation is at 70% - the JSON intent extractor and the BFS join compiler are both built. Experimental evaluation and benchmarking is at 40% - the 100-query test suite and injection cases are prepared, and I'm running them now. Thesis writing is roughly half done. The remaining work before the final defense is mostly running the benchmark to completion and writing up the results.</a:t>
+              <a:t>This is where I actually stand right now. Literature review, problem definition, and the conceptual architecture design are all complete. The semantic layer specification is 80% done. Prototype and compiler implementation is at 70% - the JSON intent extractor and the BFS join compiler are both built. Experimental evaluation and benchmarking is at 60% - I have executed the full 107-query benchmark for AEGIS against the B1 baseline and independently verified two of the four planned metrics, unsafe query execution rate and query execution validity, via true database execution rather than just checking that the compiler did not raise an exception. The other three baselines, B2 through B4, and the remaining two metrics, semantic term coverage and latency, are still outstanding. Thesis writing is roughly half done. The remaining work before the final defense is running those baselines and metrics to completion and writing up the results.</a:t>
             </a:r>
           </a:p>
         </p:txBody>
@@ -6973,7 +6973,7 @@
                         </a:defRPr>
                       </a:pPr>
                       <a:r>
-                        <a:t>Seq2SQL [11]</a:t>
+                        <a:t>Seq2SQL / G-SQL / TriSQL [11,7,8]</a:t>
                       </a:r>
                     </a:p>
                   </a:txBody>
@@ -15954,7 +15954,7 @@
                         </a:defRPr>
                       </a:pPr>
                       <a:r>
-                        <a:t>100%</a:t>
+                        <a:t>60%</a:t>
                       </a:r>
                     </a:p>
                   </a:txBody>
@@ -15975,7 +15975,7 @@
                         </a:defRPr>
                       </a:pPr>
                       <a:r>
-                        <a:t>107-query benchmark executed &amp; independently verified via true DB execution</a:t>
+                        <a:t>B1 vs AEGIS: 107-query benchmark executed &amp; independently verified via true DB execution (UQER, QEV); B2-B4 baselines and STC/latency measurement remain</a:t>
                       </a:r>
                     </a:p>
                   </a:txBody>
@@ -18148,7 +18148,7 @@
                 </a:solidFill>
                 <a:latin typeface="Times New Roman"/>
               </a:rPr>
-              <a:t>• 7 queries deliberately outside the semantic layer’s vocabulary, testing behavior at the edge rather than only in-scope success (see notes).</a:t>
+              <a:t>• 7 queries deliberately outside the semantic layer’s vocabulary, testing behavior at the edge rather than only in-scope success.</a:t>
             </a:r>
           </a:p>
           <a:p>
@@ -18170,7 +18170,7 @@
                 </a:solidFill>
                 <a:latin typeface="Times New Roman"/>
               </a:rPr>
-              <a:t>Four Baseline Comparisons (B1 executed against AEGIS; B2–B4 remain future work):</a:t>
+              <a:t>Four Baseline Comparisons (B1 executed against AEGIS; B2-B4 remain future work):</a:t>
             </a:r>
           </a:p>
           <a:p>
@@ -18835,7 +18835,7 @@
                         </a:defRPr>
                       </a:pPr>
                       <a:r>
-                        <a:t>AEGIS 100% safe (0/107) · Baseline 98.1% (1 genuine violation — see notes)</a:t>
+                        <a:t>AEGIS 100% safe (0/107) · Baseline 98.1% (1 genuine violation)</a:t>
                       </a:r>
                     </a:p>
                   </a:txBody>
@@ -18901,7 +18901,7 @@
                         </a:defRPr>
                       </a:pPr>
                       <a:r>
-                        <a:t>AEGIS 93.5% (100/107) · Baseline 25.2% (27/107) — true DB execution</a:t>
+                        <a:t>AEGIS 93.5% (100/107) · Baseline 25.2% (27/107) - true DB execution</a:t>
                       </a:r>
                     </a:p>
                   </a:txBody>
@@ -18963,7 +18963,7 @@
                         </a:defRPr>
                       </a:pPr>
                       <a:r>
-                        <a:t>Not yet quantified — future work (see notes)</a:t>
+                        <a:t>Not yet quantified - future work</a:t>
                       </a:r>
                     </a:p>
                   </a:txBody>
@@ -19029,7 +19029,7 @@
                         </a:defRPr>
                       </a:pPr>
                       <a:r>
-                        <a:t>Not yet measured — future work</a:t>
+                        <a:t>Not yet measured - future work</a:t>
                       </a:r>
                     </a:p>
                   </a:txBody>

</xml_diff>

<commit_message>
Align mid defense speaker notes
</commit_message>
<xml_diff>
--- a/docs/scripts/Md_Riaz_Mid_Defense_Final_0322310105101024.pptx
+++ b/docs/scripts/Md_Riaz_Mid_Defense_Final_0322310105101024.pptx
@@ -606,7 +606,7 @@
           <a:lstStyle/>
           <a:p>
             <a:r>
-              <a:t>The previous slide focused narrowly on text-to-SQL. This one widens the lens to the full related-work landscape I reviewed for the thesis - natural language database interfaces, text-to-SQL, natural language visualization, dashboard generation, and semantic layers - scored across seven properties. Full citations for every system are on my references slide at the end, matching the bracketed numbers in this table. Reading down the table: the classic text-to-SQL systems - Spider, BIRD, Seq2SQL, G-SQL, and TriSQL - all handle NL parsing and nothing else, and NaLIR, an early interactive natural-language-to-SQL interface, was evaluated with a real user study but is otherwise the same profile. RAT-SQL and PICARD get partial credit for constraining SQL to valid grammar and schema-scoped entities. nl4dv, a toolkit that turns natural language questions into chart specifications, adds visualization. DashBot, which uses reinforcement learning to compose dashboards, adds dashboard composition with partial widget persistence, evaluated on real public Vega datasets. Veezoo, from Lehmann et al., is the one system that actually has a working semantic layer - a commercial product with an editable Knowledge Graph - but purely for usability, not safety. And AEGIS, in the last row, is the only system with a checkmark in every column, and the only one evaluated on a production schema rather than a benchmark, an in-memory dataset, or a public example dataset. That is the gap this thesis is built to close.</a:t>
+              <a:t>This slide widens the lens from individual papers to the full related-work landscape I reviewed for the thesis. I am comparing natural language database interfaces, text-to-SQL systems, visualization tools, dashboard generation work, and semantic-layer systems across the properties my thesis needs. The main point I would explain to the committee is this: each prior stream solves only part of the problem. Spider, BIRD, Seq2SQL, G-SQL, and TriSQL mainly focus on NL parsing and SQL accuracy. RAT-SQL and PICARD add grammar or schema constraints, but they still do not model user permission or reusable reporting artifacts. nl4dv and DashBot help with visualization or dashboard generation, but they do not provide safe database execution. Veezoo has the strongest semantic-layer idea, but it is designed for usability, not SQL safety. AEGIS is placed in the last row to show the intended combination: semantic layer, safe SQL, visualization, widget persistence, and coverage validation. I should describe the evaluation carefully as a seeded nopCommerce prototype evaluation, not a deployed production claim.</a:t>
             </a:r>
           </a:p>
         </p:txBody>
@@ -1096,7 +1096,7 @@
           <a:lstStyle/>
           <a:p>
             <a:r>
-              <a:t>The semantic layer is the mechanism behind stages 2 and 3 of the pipeline, and it's really the core theoretical contribution of this thesis. It's built from three finite registries - approved metrics, approved dimensions, and approved analytical patterns - so every reachable query becomes a bounded (metric, dimension, pattern) triple from those registries, never an unconstrained SQL string. Anything outside those registries is structurally invisible to the model - not a coverage gap, that's literally the access-control mechanism. To show how it works: if a user asks for revenue by category, the compiler walks Order to OrderItem to Product to Category; for revenue by country, it walks Order to Address to Country. The relationships are defined once, and the compiler finds the shortest path automatically through graph search. Any term outside the closed vocabulary gets rejected before compilation even starts - enforced by validation, not convention. If the committee asks for concrete numbers: the current nopCommerce prototype builds this with 15 metrics, 34 dimensions, and 11 analytical patterns across 11 join paths, touching 12 of the schema's 126 tables - the other 114 are system, CMS, and permission tables with no analytics relevance, so their exclusion is the access-control mechanism working exactly as the formal model predicts, not a coverage limitation. The 15 x 34 x 11 combination gives roughly 5,610 enumerable, auditable (metric, dimension, pattern) triples - the complete, checkable set of questions this configuration can answer, which is the empirical grounding for the formal safe-query-space claim in the methodology chapter.</a:t>
+              <a:t>This is the core mechanism of the thesis. The semantic layer is made from approved metrics, approved dimensions, analytical patterns, and join paths. So instead of allowing the LLM to invent table names, column names, or raw SQL, AEGIS asks the model to select from a bounded vocabulary. For example, revenue by category maps through Order, OrderItem, Product, and Category; revenue by country maps through Order, Address, and Country. The compiler then uses the join graph to find the path. I should also be honest about the current limitation: the closed vocabulary prevents direct free-form SQL generation, but it does not yet perfectly detect every unsupported question. In the benchmark, some difficult questions still produced safe but semantically wrong in-scope SQL instead of asking for clarification. So the claim here is not perfect understanding; the claim is bounded, auditable SQL construction with scope-detection improvement left for future work.</a:t>
             </a:r>
           </a:p>
         </p:txBody>
@@ -1516,7 +1516,7 @@
           <a:lstStyle/>
           <a:p>
             <a:r>
-              <a:t>These are the four metrics for the final defense, and unlike the mid-defense draft of this slide, two of them are now real, measured numbers rather than expectations. Unsafe Query Execution Rate: I actually executed all 107 recorded SQL statements - both AEGIS's and the baseline's - against the real seeded MySQL database and scanned for genuine DML/DDL constructs, not just a keyword match, since a naive scan flags things like UNION ALL inside a legitimate recursive date-series query as if it were dangerous. After excluding those false positives, AEGIS has zero violations across all 107 queries, and the baseline has exactly one: query 105, the disguised write-request case. I asked, in plain business language, to cancel all orders stuck in Pending for more than 30 days - no adversarial framing at all. The baseline LLM produced a real, executable UPDATE ... SET OrderStatusId = 40 ...; COMMIT; statement. AEGIS cannot express a write intent at all, so it silently returned a safe, read-only listing of the matching orders instead. That's the single strongest piece of safety evidence in this whole dataset. Query Execution Validity: I went further than just checking whether the compiler raised a Python exception - I actually ran every one of the 107 SQL strings against the real database. AEGIS: 93.5%, with seven honest, individually diagnosed failures - three are relative-date phrases like 'this morning' passed through as literal DATETIME values instead of being converted to a date range, three are compiler syntax edge cases, and one is a join referencing a table alias that was never added to the FROM clause. Baseline: 25.2%, mostly hallucinated columns and tables, and SQL Server syntax bleeding into supposedly-MySQL output. If asked why AEGIS isn't at 100%: because I verified it against a real database rather than just trusting that it compiled, and a defensible 93.5% with explained failures is more credible than an unverifiable 100%. Semantic correctness is separate from execution validity: some harder requests in the same 107-query benchmark still produce safe SQL that does not answer the user's real intent, so correctness and clarification behavior need a separate annotated evaluation. Latency is also still not instrumented.</a:t>
+              <a:t>This chart is the clearest quantitative slide in the presentation. I would explain it carefully, because it measures execution behavior, not full answer correctness. The denominator is 107 mixed natural-language reporting requests. The red bar shows unsafe SQL count, and the blue bar shows how many generated SQL queries executed successfully against the seeded MySQL database. For B1, the direct LLM-to-SQL baseline, only 27 out of 107 SQL outputs executed without database error, and it produced one genuine unsafe write query. For AEGIS, 100 out of 107 executed without database error, and unsafe SQL count was zero. For B3, the template-only baseline, 104 out of 107 executed without database error. B3 is included to show that the downstream semantic mapper and compiler are strong even without an LLM, but B3 is only keyword based, so it does not prove semantic understanding. The important message is: AEGIS greatly improves safety and execution validity compared with direct LLM-to-SQL, while correctness and latency still need separate evaluation.</a:t>
             </a:r>
           </a:p>
         </p:txBody>
@@ -15782,7 +15782,7 @@
                 </a:solidFill>
                 <a:latin typeface="Times New Roman"/>
               </a:rPr>
-              <a:t>15. Evaluation Metrics &amp; Expected Results</a:t>
+              <a:t>15. Evaluation Metrics &amp; Results</a:t>
             </a:r>
           </a:p>
           <a:p>
@@ -15804,7 +15804,7 @@
                 </a:solidFill>
                 <a:latin typeface="Times New Roman"/>
               </a:rPr>
-              <a:t>16. Beneficiaries &amp; Expected Impact</a:t>
+              <a:t>16. Evaluation Summary Table</a:t>
             </a:r>
           </a:p>
           <a:p>
@@ -15826,7 +15826,7 @@
                 </a:solidFill>
                 <a:latin typeface="Times New Roman"/>
               </a:rPr>
-              <a:t>17. System Scope &amp; Limitations</a:t>
+              <a:t>17. Beneficiaries &amp; Expected Impact</a:t>
             </a:r>
           </a:p>
           <a:p>
@@ -15848,7 +15848,7 @@
                 </a:solidFill>
                 <a:latin typeface="Times New Roman"/>
               </a:rPr>
-              <a:t>18. Future Research Plan &amp; Roadmap</a:t>
+              <a:t>18. System Scope &amp; Limitations</a:t>
             </a:r>
           </a:p>
           <a:p>
@@ -15870,7 +15870,7 @@
                 </a:solidFill>
                 <a:latin typeface="Times New Roman"/>
               </a:rPr>
-              <a:t>19. References</a:t>
+              <a:t>19. Future Research Plan &amp; Roadmap</a:t>
             </a:r>
           </a:p>
           <a:p>
@@ -15892,7 +15892,29 @@
                 </a:solidFill>
                 <a:latin typeface="Times New Roman"/>
               </a:rPr>
-              <a:t>20. Questions &amp; Discussion</a:t>
+              <a:t>20. References</a:t>
+            </a:r>
+          </a:p>
+          <a:p>
+            <a:pPr marL="256032" indent="-256032">
+              <a:lnSpc>
+                <a:spcPct val="108000"/>
+              </a:lnSpc>
+              <a:spcBef>
+                <a:spcPts val="300"/>
+              </a:spcBef>
+              <a:spcAft>
+                <a:spcPts val="700"/>
+              </a:spcAft>
+            </a:pPr>
+            <a:r>
+              <a:rPr b="0" i="0" sz="1600">
+                <a:solidFill>
+                  <a:srgbClr val="333333"/>
+                </a:solidFill>
+                <a:latin typeface="Times New Roman"/>
+              </a:rPr>
+              <a:t>21. Questions &amp; Discussion</a:t>
             </a:r>
           </a:p>
         </p:txBody>

</xml_diff>

<commit_message>
Update thesis evaluation and presentation materials
</commit_message>
<xml_diff>
--- a/docs/scripts/Md_Riaz_Mid_Defense_Final_0322310105101024.pptx
+++ b/docs/scripts/Md_Riaz_Mid_Defense_Final_0322310105101024.pptx
@@ -6039,7 +6039,7 @@
         <p:spPr>
           <a:xfrm>
             <a:off x="1527048" y="4023360"/>
-            <a:ext cx="3877056" cy="1892807"/>
+            <a:ext cx="3877056" cy="1600200"/>
           </a:xfrm>
           <a:prstGeom prst="rect">
             <a:avLst/>
@@ -6089,16 +6089,6 @@
             </a:pPr>
             <a:r>
               <a:t>Batch: 16th</a:t>
-            </a:r>
-          </a:p>
-          <a:p>
-            <a:pPr>
-              <a:defRPr sz="1600" b="0">
-                <a:latin typeface="Times New Roman"/>
-              </a:defRPr>
-            </a:pPr>
-            <a:r>
-              <a:t>Semester: 7th</a:t>
             </a:r>
           </a:p>
           <a:p>

</xml_diff>

<commit_message>
Fix mid defense title slide layout
</commit_message>
<xml_diff>
--- a/docs/scripts/Md_Riaz_Mid_Defense_Final_0322310105101024.pptx
+++ b/docs/scripts/Md_Riaz_Mid_Defense_Final_0322310105101024.pptx
@@ -6195,6 +6195,9 @@
           <a:lstStyle/>
           <a:p>
             <a:pPr>
+              <a:lnSpc>
+                <a:spcPct val="116000"/>
+              </a:lnSpc>
               <a:defRPr sz="2000" b="1">
                 <a:latin typeface="Times New Roman"/>
               </a:defRPr>
@@ -6205,6 +6208,9 @@
           </a:p>
           <a:p>
             <a:pPr>
+              <a:lnSpc>
+                <a:spcPct val="116000"/>
+              </a:lnSpc>
               <a:defRPr sz="1600" b="0">
                 <a:latin typeface="Times New Roman"/>
               </a:defRPr>
@@ -6215,6 +6221,9 @@
           </a:p>
           <a:p>
             <a:pPr>
+              <a:lnSpc>
+                <a:spcPct val="116000"/>
+              </a:lnSpc>
               <a:defRPr sz="1600" b="0">
                 <a:latin typeface="Times New Roman"/>
               </a:defRPr>
@@ -6225,6 +6234,9 @@
           </a:p>
           <a:p>
             <a:pPr>
+              <a:lnSpc>
+                <a:spcPct val="116000"/>
+              </a:lnSpc>
               <a:defRPr sz="1600" b="0">
                 <a:latin typeface="Times New Roman"/>
               </a:defRPr>
@@ -6235,6 +6247,9 @@
           </a:p>
           <a:p>
             <a:pPr>
+              <a:lnSpc>
+                <a:spcPct val="116000"/>
+              </a:lnSpc>
               <a:defRPr sz="1600" b="0">
                 <a:latin typeface="Times New Roman"/>
               </a:defRPr>
@@ -6301,6 +6316,9 @@
           <a:lstStyle/>
           <a:p>
             <a:pPr>
+              <a:lnSpc>
+                <a:spcPct val="100000"/>
+              </a:lnSpc>
               <a:defRPr sz="2000" b="1">
                 <a:latin typeface="Times New Roman"/>
               </a:defRPr>
@@ -6311,6 +6329,9 @@
           </a:p>
           <a:p>
             <a:pPr>
+              <a:lnSpc>
+                <a:spcPct val="100000"/>
+              </a:lnSpc>
               <a:defRPr sz="1600" b="0">
                 <a:latin typeface="Times New Roman"/>
               </a:defRPr>
@@ -6321,6 +6342,9 @@
           </a:p>
           <a:p>
             <a:pPr>
+              <a:lnSpc>
+                <a:spcPct val="100000"/>
+              </a:lnSpc>
               <a:defRPr sz="1600" b="0">
                 <a:latin typeface="Times New Roman"/>
               </a:defRPr>

</xml_diff>

<commit_message>
Update mid defense speaker notes
</commit_message>
<xml_diff>
--- a/docs/scripts/Md_Riaz_Mid_Defense_Final_0322310105101024.pptx
+++ b/docs/scripts/Md_Riaz_Mid_Defense_Final_0322310105101024.pptx
@@ -538,7 +538,7 @@
           <a:lstStyle/>
           <a:p>
             <a:r>
-              <a:t>Good [morning/afternoon], respected Chairman and committee members. My name is Md. Riaz, and this is my mid-defense presentation on AEGIS - a constraint-based architecture for safe, LLM-assisted natural language analytics, under the supervision of Mst. Sahela Rahman. Over the next slides I will walk through the problem I am addressing, the related work, my proposed architecture, my current progress, and what remains before the final defense. Let me start with the background.</a:t>
+              <a:t>Good [morning/afternoon], respected Chairman and committee members. My name is Md. Riaz, and this is my mid-defense presentation on AEGIS - a constraint-based architecture for safe, LLM-assisted natural language analytics, under the supervision of Mst. Sahela Rahman. I will briefly introduce the problem, summarize the related work, explain the proposed architecture, present the current evaluation results, and close with the remaining work before the final defense. I will begin with the presentation outline.</a:t>
             </a:r>
           </a:p>
         </p:txBody>
@@ -1308,7 +1308,7 @@
           <a:lstStyle/>
           <a:p>
             <a:r>
-              <a:t>Here is the road map for the next few minutes. I will start with the background and the problem, then work through the literature one system at a time and the gaps it exposes. From there I move to my research questions and objectives, then the methodology - the research process, the paradigm shift, the pipeline, the semantic layer, and the threat model. After that I show where I currently stand and the evaluation plan. I close with who this benefits, the limitations I recognise, and what remains before the final defense.</a:t>
+              <a:t>Here is the road map for the next few minutes. I will start with the introduction and the problem statement, then work through the literature one system at a time and the gaps it exposes. From there I move to my research questions and objectives, then the methodology - the research process, the paradigm shift, the pipeline, the semantic layer, and the threat model. After that I show the current benchmark results and evaluation findings. I close with who this benefits, the limitations I recognise, and what remains before the final defense.</a:t>
             </a:r>
           </a:p>
         </p:txBody>

</xml_diff>